<commit_message>
chore: add vite error log file for debugging websocket proxy connection issues
</commit_message>
<xml_diff>
--- a/docs/SECOND_REVIEW_FILLED.pptx
+++ b/docs/SECOND_REVIEW_FILLED.pptx
@@ -5,7 +5,7 @@
     <p:sldMasterId id="2147483648" r:id="rId1"/>
   </p:sldMasterIdLst>
   <p:notesMasterIdLst>
-    <p:notesMasterId r:id="rId19"/>
+    <p:notesMasterId r:id="rId20"/>
   </p:notesMasterIdLst>
   <p:sldIdLst>
     <p:sldId id="256" r:id="rId2"/>
@@ -24,7 +24,8 @@
     <p:sldId id="404" r:id="rId15"/>
     <p:sldId id="395" r:id="rId16"/>
     <p:sldId id="405" r:id="rId17"/>
-    <p:sldId id="263" r:id="rId18"/>
+    <p:sldId id="412" r:id="rId18"/>
+    <p:sldId id="263" r:id="rId19"/>
   </p:sldIdLst>
   <p:sldSz cx="9144000" cy="5143500" type="screen16x9"/>
   <p:notesSz cx="6858000" cy="9144000"/>
@@ -229,7 +230,7 @@
           <a:p>
             <a:fld id="{23456805-9FF0-4934-BDCD-CD6CD9C90D87}" type="datetimeFigureOut">
               <a:rPr lang="en-US" smtClean="0"/>
-              <a:t>7/2/2026</a:t>
+              <a:t>7/7/2026</a:t>
             </a:fld>
             <a:endParaRPr lang="en-US"/>
           </a:p>
@@ -625,7 +626,7 @@
           <a:p>
             <a:fld id="{94EB8EBC-5222-431C-84DD-DD60662C159C}" type="datetime3">
               <a:rPr lang="en-US" smtClean="0"/>
-              <a:t>2 July 2026</a:t>
+              <a:t>7 July 2026</a:t>
             </a:fld>
             <a:endParaRPr lang="en-US" dirty="0"/>
           </a:p>
@@ -800,7 +801,7 @@
           <a:p>
             <a:fld id="{098E28DC-53CF-4642-AB77-F3F3B8864F72}" type="datetime3">
               <a:rPr lang="en-US" smtClean="0"/>
-              <a:t>2 July 2026</a:t>
+              <a:t>7 July 2026</a:t>
             </a:fld>
             <a:endParaRPr lang="en-US" dirty="0"/>
           </a:p>
@@ -985,7 +986,7 @@
           <a:p>
             <a:fld id="{1967ACE5-42CA-4EDC-8760-DD2585F04707}" type="datetime3">
               <a:rPr lang="en-US" smtClean="0"/>
-              <a:t>2 July 2026</a:t>
+              <a:t>7 July 2026</a:t>
             </a:fld>
             <a:endParaRPr lang="en-US" dirty="0"/>
           </a:p>
@@ -1160,7 +1161,7 @@
           <a:p>
             <a:fld id="{2DB9DF8F-09D3-46AE-87C0-0E6AC09D07A6}" type="datetime3">
               <a:rPr lang="en-US" smtClean="0"/>
-              <a:t>2 July 2026</a:t>
+              <a:t>7 July 2026</a:t>
             </a:fld>
             <a:endParaRPr lang="en-US" dirty="0"/>
           </a:p>
@@ -1412,7 +1413,7 @@
           <a:p>
             <a:fld id="{5253FD35-0CB4-474A-9599-30C5D4C0E287}" type="datetime3">
               <a:rPr lang="en-US" smtClean="0"/>
-              <a:t>2 July 2026</a:t>
+              <a:t>7 July 2026</a:t>
             </a:fld>
             <a:endParaRPr lang="en-US" dirty="0"/>
           </a:p>
@@ -1648,7 +1649,7 @@
           <a:p>
             <a:fld id="{605DD382-1684-47A7-8447-FF64349E7EA4}" type="datetime3">
               <a:rPr lang="en-US" smtClean="0"/>
-              <a:t>2 July 2026</a:t>
+              <a:t>7 July 2026</a:t>
             </a:fld>
             <a:endParaRPr lang="en-US" dirty="0"/>
           </a:p>
@@ -2019,7 +2020,7 @@
           <a:p>
             <a:fld id="{10666D20-7225-440A-88E7-D6F958D48F89}" type="datetime3">
               <a:rPr lang="en-US" smtClean="0"/>
-              <a:t>2 July 2026</a:t>
+              <a:t>7 July 2026</a:t>
             </a:fld>
             <a:endParaRPr lang="en-US" dirty="0"/>
           </a:p>
@@ -2143,7 +2144,7 @@
           <a:p>
             <a:fld id="{81CB1683-EA87-4A2C-B387-AB50EB5CC6D6}" type="datetime3">
               <a:rPr lang="en-US" smtClean="0"/>
-              <a:t>2 July 2026</a:t>
+              <a:t>7 July 2026</a:t>
             </a:fld>
             <a:endParaRPr lang="en-US" dirty="0"/>
           </a:p>
@@ -2245,7 +2246,7 @@
           <a:p>
             <a:fld id="{56E2D354-87FD-45C8-B30B-40E925ADA766}" type="datetime3">
               <a:rPr lang="en-US" smtClean="0"/>
-              <a:t>2 July 2026</a:t>
+              <a:t>7 July 2026</a:t>
             </a:fld>
             <a:endParaRPr lang="en-US" dirty="0"/>
           </a:p>
@@ -2527,7 +2528,7 @@
           <a:p>
             <a:fld id="{236FCBC9-030E-4CA2-939A-297D2E5B0AF9}" type="datetime3">
               <a:rPr lang="en-US" smtClean="0"/>
-              <a:t>2 July 2026</a:t>
+              <a:t>7 July 2026</a:t>
             </a:fld>
             <a:endParaRPr lang="en-US" dirty="0"/>
           </a:p>
@@ -2786,7 +2787,7 @@
           <a:p>
             <a:fld id="{C5BC5EF5-3D0C-410F-81FA-0155F6DDC1A3}" type="datetime3">
               <a:rPr lang="en-US" smtClean="0"/>
-              <a:t>2 July 2026</a:t>
+              <a:t>7 July 2026</a:t>
             </a:fld>
             <a:endParaRPr lang="en-US" dirty="0"/>
           </a:p>
@@ -3007,7 +3008,7 @@
           <a:p>
             <a:fld id="{3EE8C92B-93F9-4684-984D-12FC30565B2E}" type="datetime3">
               <a:rPr lang="en-US" smtClean="0"/>
-              <a:t>2 July 2026</a:t>
+              <a:t>7 July 2026</a:t>
             </a:fld>
             <a:endParaRPr lang="en-US" dirty="0"/>
           </a:p>
@@ -4041,7 +4042,7 @@
           <a:p>
             <a:fld id="{305CE664-CC6B-43B1-BCF8-14EAD95F037A}" type="datetime3">
               <a:rPr lang="en-US" smtClean="0"/>
-              <a:t>2 July 2026</a:t>
+              <a:t>7 July 2026</a:t>
             </a:fld>
             <a:endParaRPr lang="en-US" dirty="0"/>
           </a:p>
@@ -4205,7 +4206,7 @@
           <a:p>
             <a:fld id="{DE11E864-39B2-4D9A-938E-DF8E5B1FD578}" type="datetime3">
               <a:rPr lang="en-US" smtClean="0"/>
-              <a:t>2 July 2026</a:t>
+              <a:t>7 July 2026</a:t>
             </a:fld>
             <a:endParaRPr lang="en-US" dirty="0"/>
           </a:p>
@@ -5180,7 +5181,7 @@
           <a:p>
             <a:fld id="{2B573973-4A1E-4C7C-AAB7-BDE9EAC7FD5C}" type="datetime3">
               <a:rPr lang="en-US" smtClean="0"/>
-              <a:t>2 July 2026</a:t>
+              <a:t>7 July 2026</a:t>
             </a:fld>
             <a:endParaRPr lang="en-US" dirty="0"/>
           </a:p>
@@ -5957,7 +5958,7 @@
                   <a:spcPts val="600"/>
                 </a:spcAft>
               </a:pPr>
-              <a:t>2 July 2026</a:t>
+              <a:t>7 July 2026</a:t>
             </a:fld>
             <a:endParaRPr lang="en-US" sz="800">
               <a:solidFill>
@@ -6272,7 +6273,7 @@
           <a:p>
             <a:fld id="{2FFD4BED-E319-4DA0-96BF-17657C6E3A60}" type="datetime3">
               <a:rPr lang="en-US" smtClean="0"/>
-              <a:t>2 July 2026</a:t>
+              <a:t>7 July 2026</a:t>
             </a:fld>
             <a:endParaRPr lang="en-US" dirty="0"/>
           </a:p>
@@ -6442,7 +6443,7 @@
         </p:nvSpPr>
         <p:spPr>
           <a:xfrm>
-            <a:off x="78853" y="452831"/>
+            <a:off x="78853" y="324981"/>
             <a:ext cx="8986294" cy="4493538"/>
           </a:xfrm>
           <a:prstGeom prst="rect">
@@ -6645,7 +6646,55 @@
             <a:pPr algn="just"/>
             <a:r>
               <a:rPr lang="en-IN" sz="1100" dirty="0"/>
-              <a:t>[11] S. Mishra, et al., "</a:t>
+              <a:t>[11] </a:t>
+            </a:r>
+            <a:r>
+              <a:rPr lang="en-IN" sz="1100" dirty="0" err="1"/>
+              <a:t>shivam</a:t>
+            </a:r>
+            <a:r>
+              <a:rPr lang="en-IN" sz="1100" dirty="0"/>
+              <a:t> </a:t>
+            </a:r>
+            <a:r>
+              <a:rPr lang="en-IN" sz="1100" dirty="0" err="1"/>
+              <a:t>kumar</a:t>
+            </a:r>
+            <a:r>
+              <a:rPr lang="en-IN" sz="1100" dirty="0"/>
+              <a:t>, Zafar </a:t>
+            </a:r>
+            <a:r>
+              <a:rPr lang="en-IN" sz="1100" dirty="0" err="1"/>
+              <a:t>hussain</a:t>
+            </a:r>
+            <a:r>
+              <a:rPr lang="en-IN" sz="1100" dirty="0"/>
+              <a:t>, Shaaz </a:t>
+            </a:r>
+            <a:r>
+              <a:rPr lang="en-IN" sz="1100" dirty="0" err="1"/>
+              <a:t>alfaiz</a:t>
+            </a:r>
+            <a:r>
+              <a:rPr lang="en-IN" sz="1100" dirty="0"/>
+              <a:t> and Aman </a:t>
+            </a:r>
+            <a:r>
+              <a:rPr lang="en-IN" sz="1100" dirty="0" err="1"/>
+              <a:t>shankar</a:t>
+            </a:r>
+            <a:r>
+              <a:rPr lang="en-IN" sz="1100" dirty="0"/>
+              <a:t> </a:t>
+            </a:r>
+            <a:r>
+              <a:rPr lang="en-IN" sz="1100" dirty="0" err="1"/>
+              <a:t>mandale</a:t>
+            </a:r>
+            <a:r>
+              <a:rPr lang="en-IN" sz="1100" dirty="0"/>
+              <a:t> (2026). "</a:t>
             </a:r>
             <a:r>
               <a:rPr lang="en-IN" sz="1100" dirty="0" err="1"/>
@@ -6653,23 +6702,15 @@
             </a:r>
             <a:r>
               <a:rPr lang="en-IN" sz="1100" dirty="0"/>
-              <a:t>: A Scalable Multiplayer Gamified Quiz Platform using Node.js and Socket.IO," </a:t>
+              <a:t>". </a:t>
             </a:r>
             <a:r>
               <a:rPr lang="en-IN" sz="1100" i="1" dirty="0"/>
-              <a:t>Int. J. </a:t>
-            </a:r>
-            <a:r>
-              <a:rPr lang="en-IN" sz="1100" i="1" dirty="0" err="1"/>
-              <a:t>Comput</a:t>
-            </a:r>
-            <a:r>
-              <a:rPr lang="en-IN" sz="1100" i="1" dirty="0"/>
-              <a:t>. Sci. Eng.</a:t>
+              <a:t>INTERNATIONAL JOURNAL OF EMERGING TRENDS IN ENGINEERING AND DEVELOPMENT (IJETED)</a:t>
             </a:r>
             <a:r>
               <a:rPr lang="en-IN" sz="1100" dirty="0"/>
-              <a:t>, vol. 18, no. 2, pp. 245-251, Feb 2026.</a:t>
+              <a:t>, vol. 16, Issue 3, 2026, pp.9/1-9/5. DOI: 10.26808/RS.2026.c6be38.</a:t>
             </a:r>
           </a:p>
           <a:p>
@@ -6791,7 +6832,7 @@
           <a:p>
             <a:fld id="{756D0CD2-9846-482E-BF67-7C2753030DC2}" type="datetime3">
               <a:rPr lang="en-US" smtClean="0"/>
-              <a:t>2 July 2026</a:t>
+              <a:t>7 July 2026</a:t>
             </a:fld>
             <a:endParaRPr lang="en-US" dirty="0"/>
           </a:p>
@@ -7210,7 +7251,7 @@
           <a:p>
             <a:fld id="{24A434A4-5EBF-4C57-A471-F9649EE16CF8}" type="datetime3">
               <a:rPr lang="en-US" smtClean="0"/>
-              <a:t>2 July 2026</a:t>
+              <a:t>7 July 2026</a:t>
             </a:fld>
             <a:endParaRPr lang="en-US" dirty="0"/>
           </a:p>
@@ -7278,6 +7319,255 @@
       </p:grpSpPr>
       <p:sp>
         <p:nvSpPr>
+          <p:cNvPr id="4" name="Date Placeholder 3">
+            <a:extLst>
+              <a:ext uri="{FF2B5EF4-FFF2-40B4-BE49-F238E27FC236}">
+                <a16:creationId xmlns:a16="http://schemas.microsoft.com/office/drawing/2014/main" id="{B755A755-F616-3101-EE86-A096891EF83B}"/>
+              </a:ext>
+            </a:extLst>
+          </p:cNvPr>
+          <p:cNvSpPr>
+            <a:spLocks noGrp="1"/>
+          </p:cNvSpPr>
+          <p:nvPr>
+            <p:ph type="dt" sz="half" idx="10"/>
+          </p:nvPr>
+        </p:nvSpPr>
+        <p:spPr/>
+        <p:txBody>
+          <a:bodyPr/>
+          <a:lstStyle/>
+          <a:p>
+            <a:fld id="{2DB9DF8F-09D3-46AE-87C0-0E6AC09D07A6}" type="datetime3">
+              <a:rPr lang="en-US" smtClean="0"/>
+              <a:t>7 July 2026</a:t>
+            </a:fld>
+            <a:endParaRPr lang="en-US" dirty="0"/>
+          </a:p>
+        </p:txBody>
+      </p:sp>
+      <p:sp>
+        <p:nvSpPr>
+          <p:cNvPr id="5" name="Footer Placeholder 4">
+            <a:extLst>
+              <a:ext uri="{FF2B5EF4-FFF2-40B4-BE49-F238E27FC236}">
+                <a16:creationId xmlns:a16="http://schemas.microsoft.com/office/drawing/2014/main" id="{088F38D5-B1E3-58BD-DB86-872A38614B5D}"/>
+              </a:ext>
+            </a:extLst>
+          </p:cNvPr>
+          <p:cNvSpPr>
+            <a:spLocks noGrp="1"/>
+          </p:cNvSpPr>
+          <p:nvPr>
+            <p:ph type="ftr" sz="quarter" idx="11"/>
+          </p:nvPr>
+        </p:nvSpPr>
+        <p:spPr/>
+        <p:txBody>
+          <a:bodyPr/>
+          <a:lstStyle/>
+          <a:p>
+            <a:r>
+              <a:rPr lang="en-US"/>
+              <a:t>INT500 REVIEW - I</a:t>
+            </a:r>
+            <a:endParaRPr lang="en-US" dirty="0"/>
+          </a:p>
+        </p:txBody>
+      </p:sp>
+      <p:sp>
+        <p:nvSpPr>
+          <p:cNvPr id="6" name="Slide Number Placeholder 5">
+            <a:extLst>
+              <a:ext uri="{FF2B5EF4-FFF2-40B4-BE49-F238E27FC236}">
+                <a16:creationId xmlns:a16="http://schemas.microsoft.com/office/drawing/2014/main" id="{DDF61CB0-98DD-939F-290F-57B9BAF07685}"/>
+              </a:ext>
+            </a:extLst>
+          </p:cNvPr>
+          <p:cNvSpPr>
+            <a:spLocks noGrp="1"/>
+          </p:cNvSpPr>
+          <p:nvPr>
+            <p:ph type="sldNum" sz="quarter" idx="12"/>
+          </p:nvPr>
+        </p:nvSpPr>
+        <p:spPr/>
+        <p:txBody>
+          <a:bodyPr/>
+          <a:lstStyle/>
+          <a:p>
+            <a:fld id="{D57F1E4F-1CFF-5643-939E-217C01CDF565}" type="slidenum">
+              <a:rPr lang="en-US" smtClean="0"/>
+              <a:t>17</a:t>
+            </a:fld>
+            <a:endParaRPr lang="en-US" dirty="0"/>
+          </a:p>
+        </p:txBody>
+      </p:sp>
+      <p:sp>
+        <p:nvSpPr>
+          <p:cNvPr id="7" name="TextBox 6">
+            <a:extLst>
+              <a:ext uri="{FF2B5EF4-FFF2-40B4-BE49-F238E27FC236}">
+                <a16:creationId xmlns:a16="http://schemas.microsoft.com/office/drawing/2014/main" id="{A131FB57-8EF1-13EB-3238-6F5836EDB854}"/>
+              </a:ext>
+            </a:extLst>
+          </p:cNvPr>
+          <p:cNvSpPr txBox="1"/>
+          <p:nvPr/>
+        </p:nvSpPr>
+        <p:spPr>
+          <a:xfrm>
+            <a:off x="0" y="102392"/>
+            <a:ext cx="16950922" cy="3693319"/>
+          </a:xfrm>
+          <a:prstGeom prst="rect">
+            <a:avLst/>
+          </a:prstGeom>
+          <a:noFill/>
+        </p:spPr>
+        <p:txBody>
+          <a:bodyPr wrap="none" rtlCol="0">
+            <a:spAutoFit/>
+          </a:bodyPr>
+          <a:lstStyle/>
+          <a:p>
+            <a:r>
+              <a:rPr lang="en-IN" dirty="0">
+                <a:hlinkClick r:id="rId2"/>
+              </a:rPr>
+              <a:t>https://www.researchgate.net/publication/405100802_Advancing_Nursing_Education_Through_Gamification</a:t>
+            </a:r>
+            <a:br>
+              <a:rPr lang="en-IN" dirty="0"/>
+            </a:br>
+            <a:r>
+              <a:rPr lang="en-IN" dirty="0">
+                <a:hlinkClick r:id="rId3"/>
+              </a:rPr>
+              <a:t>https://europepmc.org/article/med/41943200</a:t>
+            </a:r>
+            <a:br>
+              <a:rPr lang="en-IN" dirty="0"/>
+            </a:br>
+            <a:r>
+              <a:rPr lang="en-IN" dirty="0">
+                <a:hlinkClick r:id="rId4"/>
+              </a:rPr>
+              <a:t>https://link.springer.com/article/10.1186/s12909-026-09138-2</a:t>
+            </a:r>
+            <a:br>
+              <a:rPr lang="en-IN" dirty="0"/>
+            </a:br>
+            <a:r>
+              <a:rPr lang="en-IN" dirty="0"/>
+              <a:t>https://pubmed.ncbi.nlm.nih.gov/42048998/</a:t>
+            </a:r>
+            <a:br>
+              <a:rPr lang="en-IN" dirty="0"/>
+            </a:br>
+            <a:r>
+              <a:rPr lang="en-IN" dirty="0"/>
+              <a:t>https://pubmed.ncbi.nlm.nih.gov/41498142/</a:t>
+            </a:r>
+            <a:br>
+              <a:rPr lang="en-IN" dirty="0"/>
+            </a:br>
+            <a:r>
+              <a:rPr lang="en-IN" dirty="0">
+                <a:hlinkClick r:id="rId5"/>
+              </a:rPr>
+              <a:t>https://bmjopen.bmj.com/content/16/1/e107037</a:t>
+            </a:r>
+            <a:br>
+              <a:rPr lang="en-IN" dirty="0"/>
+            </a:br>
+            <a:r>
+              <a:rPr lang="en-IN" dirty="0"/>
+              <a:t>https://pubmed.ncbi.nlm.nih.gov/41634701/</a:t>
+            </a:r>
+            <a:br>
+              <a:rPr lang="en-IN" dirty="0"/>
+            </a:br>
+            <a:r>
+              <a:rPr lang="en-IN" dirty="0"/>
+              <a:t>https://games.jmir.org/2025/1/e66289/</a:t>
+            </a:r>
+            <a:br>
+              <a:rPr lang="en-IN" dirty="0"/>
+            </a:br>
+            <a:r>
+              <a:rPr lang="en-IN" dirty="0">
+                <a:hlinkClick r:id="rId6"/>
+              </a:rPr>
+              <a:t>https://www.researchgate.net/publication/399253963_The_use_of_an_escape_room-based_learning_strategy_to_enhance_pharmacology_knowledge_among_nursing_students</a:t>
+            </a:r>
+            <a:br>
+              <a:rPr lang="en-IN" dirty="0"/>
+            </a:br>
+            <a:r>
+              <a:rPr lang="en-IN" dirty="0"/>
+              <a:t>https://pubmed.ncbi.nlm.nih.gov/28817476/</a:t>
+            </a:r>
+            <a:br>
+              <a:rPr lang="en-IN" dirty="0"/>
+            </a:br>
+            <a:r>
+              <a:rPr lang="en-IN" dirty="0">
+                <a:hlinkClick r:id="rId7"/>
+              </a:rPr>
+              <a:t>https://rspublication.com/ijeted/2026/e3/9.html</a:t>
+            </a:r>
+            <a:br>
+              <a:rPr lang="en-IN" dirty="0"/>
+            </a:br>
+            <a:br>
+              <a:rPr lang="en-IN" dirty="0"/>
+            </a:br>
+            <a:endParaRPr lang="en-IN" dirty="0"/>
+          </a:p>
+        </p:txBody>
+      </p:sp>
+    </p:spTree>
+    <p:extLst>
+      <p:ext uri="{BB962C8B-B14F-4D97-AF65-F5344CB8AC3E}">
+        <p14:creationId xmlns:p14="http://schemas.microsoft.com/office/powerpoint/2010/main" val="1878970963"/>
+      </p:ext>
+    </p:extLst>
+  </p:cSld>
+  <p:clrMapOvr>
+    <a:masterClrMapping/>
+  </p:clrMapOvr>
+  <mc:AlternateContent xmlns:mc="http://schemas.openxmlformats.org/markup-compatibility/2006" xmlns:p14="http://schemas.microsoft.com/office/powerpoint/2010/main">
+    <mc:Choice Requires="p14">
+      <p:transition spd="slow" p14:dur="59000"/>
+    </mc:Choice>
+    <mc:Fallback xmlns="">
+      <p:transition spd="slow"/>
+    </mc:Fallback>
+  </mc:AlternateContent>
+</p:sld>
+</file>
+
+<file path=ppt/slides/slide18.xml><?xml version="1.0" encoding="utf-8"?>
+<p:sld xmlns:a="http://schemas.openxmlformats.org/drawingml/2006/main" xmlns:r="http://schemas.openxmlformats.org/officeDocument/2006/relationships" xmlns:p="http://schemas.openxmlformats.org/presentationml/2006/main">
+  <p:cSld>
+    <p:spTree>
+      <p:nvGrpSpPr>
+        <p:cNvPr id="1" name=""/>
+        <p:cNvGrpSpPr/>
+        <p:nvPr/>
+      </p:nvGrpSpPr>
+      <p:grpSpPr>
+        <a:xfrm>
+          <a:off x="0" y="0"/>
+          <a:ext cx="0" cy="0"/>
+          <a:chOff x="0" y="0"/>
+          <a:chExt cx="0" cy="0"/>
+        </a:xfrm>
+      </p:grpSpPr>
+      <p:sp>
+        <p:nvSpPr>
           <p:cNvPr id="2" name="Title 1"/>
           <p:cNvSpPr>
             <a:spLocks noGrp="1"/>
@@ -7331,7 +7621,7 @@
           <a:p>
             <a:fld id="{D57F1E4F-1CFF-5643-939E-217C01CDF565}" type="slidenum">
               <a:rPr lang="en-US" smtClean="0"/>
-              <a:t>17</a:t>
+              <a:t>18</a:t>
             </a:fld>
             <a:endParaRPr lang="en-US" dirty="0"/>
           </a:p>
@@ -7354,7 +7644,7 @@
           <a:p>
             <a:fld id="{F6B04E1E-CF05-4B41-8802-CD685CA27131}" type="datetime3">
               <a:rPr lang="en-US" smtClean="0"/>
-              <a:t>2 July 2026</a:t>
+              <a:t>7 July 2026</a:t>
             </a:fld>
             <a:endParaRPr lang="en-US" dirty="0"/>
           </a:p>
@@ -7715,7 +8005,7 @@
           <a:p>
             <a:fld id="{E019806D-BBF9-4065-82F1-BB4B2025BF7F}" type="datetime3">
               <a:rPr lang="en-US" smtClean="0"/>
-              <a:t>2 July 2026</a:t>
+              <a:t>7 July 2026</a:t>
             </a:fld>
             <a:endParaRPr lang="en-US" dirty="0"/>
           </a:p>
@@ -7804,7 +8094,7 @@
           <a:p>
             <a:fld id="{2DB9DF8F-09D3-46AE-87C0-0E6AC09D07A6}" type="datetime3">
               <a:rPr lang="en-US" smtClean="0"/>
-              <a:t>2 July 2026</a:t>
+              <a:t>7 July 2026</a:t>
             </a:fld>
             <a:endParaRPr lang="en-US" dirty="0"/>
           </a:p>
@@ -8174,7 +8464,7 @@
           <p:nvPr>
             <p:extLst>
               <p:ext uri="{D42A27DB-BD31-4B8C-83A1-F6EECF244321}">
-                <p14:modId xmlns:p14="http://schemas.microsoft.com/office/powerpoint/2010/main" val="1910605918"/>
+                <p14:modId xmlns:p14="http://schemas.microsoft.com/office/powerpoint/2010/main" val="3989183816"/>
               </p:ext>
             </p:extLst>
           </p:nvPr>
@@ -8473,33 +8763,22 @@
                     <a:p>
                       <a:pPr algn="l"/>
                       <a:r>
-                        <a:rPr sz="700" b="0">
+                        <a:rPr lang="en-IN" sz="700" b="0" dirty="0">
                           <a:solidFill>
                             <a:srgbClr val="000000"/>
                           </a:solidFill>
                           <a:latin typeface="Times New Roman"/>
                         </a:rPr>
-                        <a:t>Argumentative review &amp; pedagogical analysis of gamification frameworks applied to nursing curricula.</a:t>
-                      </a:r>
-                      <a:endParaRPr lang="en-IN" sz="1000" dirty="0"/>
-                    </a:p>
-                  </a:txBody>
-                  <a:tcPr marT="34290" marB="34290"/>
-                </a:tc>
-                <a:tc>
-                  <a:txBody>
-                    <a:bodyPr/>
-                    <a:lstStyle/>
-                    <a:p>
-                      <a:pPr algn="l"/>
-                      <a:r>
-                        <a:rPr sz="700" b="0">
+                        <a:t>A review and Analysis of  gamification elements applied in nursing syllabus</a:t>
+                      </a:r>
+                      <a:r>
+                        <a:rPr sz="700" b="0" dirty="0">
                           <a:solidFill>
                             <a:srgbClr val="000000"/>
                           </a:solidFill>
                           <a:latin typeface="Times New Roman"/>
                         </a:rPr>
-                        <a:t>Existing literature on nursing education gamification; not primary data collection.</a:t>
+                        <a:t>.</a:t>
                       </a:r>
                       <a:endParaRPr lang="en-IN" sz="1000" dirty="0"/>
                     </a:p>
@@ -8513,13 +8792,13 @@
                     <a:p>
                       <a:pPr algn="l"/>
                       <a:r>
-                        <a:rPr sz="700" b="0">
+                        <a:rPr lang="en-IN" sz="700" b="0" dirty="0">
                           <a:solidFill>
                             <a:srgbClr val="000000"/>
                           </a:solidFill>
                           <a:latin typeface="Times New Roman"/>
                         </a:rPr>
-                        <a:t>Gamification strategies (XP, leaderboards, rewards) significantly increase student motivation and knowledge retention.</a:t>
+                        <a:t>This is a existing Literature on gamification in nursing ; Not a primary dataset</a:t>
                       </a:r>
                       <a:endParaRPr lang="en-IN" sz="1000" dirty="0"/>
                     </a:p>
@@ -8533,13 +8812,62 @@
                     <a:p>
                       <a:pPr algn="l"/>
                       <a:r>
-                        <a:rPr sz="700" b="0">
+                        <a:rPr lang="en-IN" sz="700" dirty="0">
+                          <a:latin typeface="Times New Roman" panose="02020603050405020304" pitchFamily="18" charset="0"/>
+                          <a:cs typeface="Times New Roman" panose="02020603050405020304" pitchFamily="18" charset="0"/>
+                        </a:rPr>
+                        <a:t>Gamification techniques (XPs, </a:t>
+                      </a:r>
+                      <a:r>
+                        <a:rPr lang="en-IN" sz="700" dirty="0" err="1">
+                          <a:latin typeface="Times New Roman" panose="02020603050405020304" pitchFamily="18" charset="0"/>
+                          <a:cs typeface="Times New Roman" panose="02020603050405020304" pitchFamily="18" charset="0"/>
+                        </a:rPr>
+                        <a:t>Led.Boa.s,etc</a:t>
+                      </a:r>
+                      <a:r>
+                        <a:rPr lang="en-IN" sz="700" dirty="0">
+                          <a:latin typeface="Times New Roman" panose="02020603050405020304" pitchFamily="18" charset="0"/>
+                          <a:cs typeface="Times New Roman" panose="02020603050405020304" pitchFamily="18" charset="0"/>
+                        </a:rPr>
+                        <a:t>) significantly increase the motivation and learning of students</a:t>
+                      </a:r>
+                    </a:p>
+                  </a:txBody>
+                  <a:tcPr marT="34290" marB="34290"/>
+                </a:tc>
+                <a:tc>
+                  <a:txBody>
+                    <a:bodyPr/>
+                    <a:lstStyle/>
+                    <a:p>
+                      <a:pPr algn="l"/>
+                      <a:r>
+                        <a:rPr sz="700" b="0" dirty="0">
                           <a:solidFill>
                             <a:srgbClr val="000000"/>
                           </a:solidFill>
                           <a:latin typeface="Times New Roman"/>
                         </a:rPr>
-                        <a:t>Establishes the theoretical basis for applying gamification in nursing; directly supports NurseQuest's XP and leveling model.</a:t>
+                        <a:t>Establishes the theoretical basis for applying gamification in nursing; directly supports </a:t>
+                      </a:r>
+                      <a:r>
+                        <a:rPr sz="700" b="0" dirty="0" err="1">
+                          <a:solidFill>
+                            <a:srgbClr val="000000"/>
+                          </a:solidFill>
+                          <a:latin typeface="Times New Roman"/>
+                        </a:rPr>
+                        <a:t>NurseQuest's</a:t>
+                      </a:r>
+                      <a:r>
+                        <a:rPr sz="700" b="0" dirty="0">
+                          <a:solidFill>
+                            <a:srgbClr val="000000"/>
+                          </a:solidFill>
+                          <a:latin typeface="Times New Roman"/>
+                        </a:rPr>
+                        <a:t> XP and leveling model.</a:t>
                       </a:r>
                       <a:endParaRPr lang="en-IN" sz="1000" dirty="0"/>
                     </a:p>
@@ -9323,7 +9651,7 @@
           <a:p>
             <a:fld id="{4E2F8081-A97F-4DB5-8CE1-E687C3C2B1EA}" type="datetime3">
               <a:rPr lang="en-US" smtClean="0"/>
-              <a:t>2 July 2026</a:t>
+              <a:t>7 July 2026</a:t>
             </a:fld>
             <a:endParaRPr lang="en-US" dirty="0"/>
           </a:p>
@@ -10656,7 +10984,7 @@
           <a:p>
             <a:fld id="{79B8DED3-A3EE-40F6-BF5C-4608A21E219C}" type="datetime3">
               <a:rPr lang="en-US" smtClean="0"/>
-              <a:t>2 July 2026</a:t>
+              <a:t>7 July 2026</a:t>
             </a:fld>
             <a:endParaRPr lang="en-US" dirty="0"/>
           </a:p>
@@ -10793,7 +11121,7 @@
           <a:p>
             <a:fld id="{2DB9DF8F-09D3-46AE-87C0-0E6AC09D07A6}" type="datetime3">
               <a:rPr lang="en-US" smtClean="0"/>
-              <a:t>2 July 2026</a:t>
+              <a:t>7 July 2026</a:t>
             </a:fld>
             <a:endParaRPr lang="en-US" dirty="0"/>
           </a:p>
@@ -12718,7 +13046,7 @@
           <a:p>
             <a:fld id="{A677CD66-4046-4467-BD12-ED7F3687165D}" type="datetime3">
               <a:rPr lang="en-US" smtClean="0"/>
-              <a:t>2 July 2026</a:t>
+              <a:t>7 July 2026</a:t>
             </a:fld>
             <a:endParaRPr lang="en-US" dirty="0"/>
           </a:p>
@@ -12812,7 +13140,7 @@
           <a:p>
             <a:fld id="{2DB9DF8F-09D3-46AE-87C0-0E6AC09D07A6}" type="datetime3">
               <a:rPr lang="en-US" smtClean="0"/>
-              <a:t>2 July 2026</a:t>
+              <a:t>7 July 2026</a:t>
             </a:fld>
             <a:endParaRPr lang="en-US" dirty="0"/>
           </a:p>
@@ -14095,7 +14423,7 @@
           <a:p>
             <a:fld id="{5A880E69-CE3A-4D4E-8C11-95F4E85341CB}" type="datetime3">
               <a:rPr lang="en-US" smtClean="0"/>
-              <a:t>2 July 2026</a:t>
+              <a:t>7 July 2026</a:t>
             </a:fld>
             <a:endParaRPr lang="en-US" dirty="0"/>
           </a:p>

</xml_diff>

<commit_message>
feat: implement authentication routes with Supabase integration and local development bypass support.
</commit_message>
<xml_diff>
--- a/docs/SECOND_REVIEW_FILLED.pptx
+++ b/docs/SECOND_REVIEW_FILLED.pptx
@@ -230,7 +230,7 @@
           <a:p>
             <a:fld id="{23456805-9FF0-4934-BDCD-CD6CD9C90D87}" type="datetimeFigureOut">
               <a:rPr lang="en-US" smtClean="0"/>
-              <a:t>7/7/2026</a:t>
+              <a:t>7/10/2026</a:t>
             </a:fld>
             <a:endParaRPr lang="en-US"/>
           </a:p>
@@ -626,7 +626,7 @@
           <a:p>
             <a:fld id="{94EB8EBC-5222-431C-84DD-DD60662C159C}" type="datetime3">
               <a:rPr lang="en-US" smtClean="0"/>
-              <a:t>7 July 2026</a:t>
+              <a:t>10 July 2026</a:t>
             </a:fld>
             <a:endParaRPr lang="en-US" dirty="0"/>
           </a:p>
@@ -801,7 +801,7 @@
           <a:p>
             <a:fld id="{098E28DC-53CF-4642-AB77-F3F3B8864F72}" type="datetime3">
               <a:rPr lang="en-US" smtClean="0"/>
-              <a:t>7 July 2026</a:t>
+              <a:t>10 July 2026</a:t>
             </a:fld>
             <a:endParaRPr lang="en-US" dirty="0"/>
           </a:p>
@@ -986,7 +986,7 @@
           <a:p>
             <a:fld id="{1967ACE5-42CA-4EDC-8760-DD2585F04707}" type="datetime3">
               <a:rPr lang="en-US" smtClean="0"/>
-              <a:t>7 July 2026</a:t>
+              <a:t>10 July 2026</a:t>
             </a:fld>
             <a:endParaRPr lang="en-US" dirty="0"/>
           </a:p>
@@ -1161,7 +1161,7 @@
           <a:p>
             <a:fld id="{2DB9DF8F-09D3-46AE-87C0-0E6AC09D07A6}" type="datetime3">
               <a:rPr lang="en-US" smtClean="0"/>
-              <a:t>7 July 2026</a:t>
+              <a:t>10 July 2026</a:t>
             </a:fld>
             <a:endParaRPr lang="en-US" dirty="0"/>
           </a:p>
@@ -1413,7 +1413,7 @@
           <a:p>
             <a:fld id="{5253FD35-0CB4-474A-9599-30C5D4C0E287}" type="datetime3">
               <a:rPr lang="en-US" smtClean="0"/>
-              <a:t>7 July 2026</a:t>
+              <a:t>10 July 2026</a:t>
             </a:fld>
             <a:endParaRPr lang="en-US" dirty="0"/>
           </a:p>
@@ -1649,7 +1649,7 @@
           <a:p>
             <a:fld id="{605DD382-1684-47A7-8447-FF64349E7EA4}" type="datetime3">
               <a:rPr lang="en-US" smtClean="0"/>
-              <a:t>7 July 2026</a:t>
+              <a:t>10 July 2026</a:t>
             </a:fld>
             <a:endParaRPr lang="en-US" dirty="0"/>
           </a:p>
@@ -2020,7 +2020,7 @@
           <a:p>
             <a:fld id="{10666D20-7225-440A-88E7-D6F958D48F89}" type="datetime3">
               <a:rPr lang="en-US" smtClean="0"/>
-              <a:t>7 July 2026</a:t>
+              <a:t>10 July 2026</a:t>
             </a:fld>
             <a:endParaRPr lang="en-US" dirty="0"/>
           </a:p>
@@ -2144,7 +2144,7 @@
           <a:p>
             <a:fld id="{81CB1683-EA87-4A2C-B387-AB50EB5CC6D6}" type="datetime3">
               <a:rPr lang="en-US" smtClean="0"/>
-              <a:t>7 July 2026</a:t>
+              <a:t>10 July 2026</a:t>
             </a:fld>
             <a:endParaRPr lang="en-US" dirty="0"/>
           </a:p>
@@ -2246,7 +2246,7 @@
           <a:p>
             <a:fld id="{56E2D354-87FD-45C8-B30B-40E925ADA766}" type="datetime3">
               <a:rPr lang="en-US" smtClean="0"/>
-              <a:t>7 July 2026</a:t>
+              <a:t>10 July 2026</a:t>
             </a:fld>
             <a:endParaRPr lang="en-US" dirty="0"/>
           </a:p>
@@ -2528,7 +2528,7 @@
           <a:p>
             <a:fld id="{236FCBC9-030E-4CA2-939A-297D2E5B0AF9}" type="datetime3">
               <a:rPr lang="en-US" smtClean="0"/>
-              <a:t>7 July 2026</a:t>
+              <a:t>10 July 2026</a:t>
             </a:fld>
             <a:endParaRPr lang="en-US" dirty="0"/>
           </a:p>
@@ -2787,7 +2787,7 @@
           <a:p>
             <a:fld id="{C5BC5EF5-3D0C-410F-81FA-0155F6DDC1A3}" type="datetime3">
               <a:rPr lang="en-US" smtClean="0"/>
-              <a:t>7 July 2026</a:t>
+              <a:t>10 July 2026</a:t>
             </a:fld>
             <a:endParaRPr lang="en-US" dirty="0"/>
           </a:p>
@@ -3008,7 +3008,7 @@
           <a:p>
             <a:fld id="{3EE8C92B-93F9-4684-984D-12FC30565B2E}" type="datetime3">
               <a:rPr lang="en-US" smtClean="0"/>
-              <a:t>7 July 2026</a:t>
+              <a:t>10 July 2026</a:t>
             </a:fld>
             <a:endParaRPr lang="en-US" dirty="0"/>
           </a:p>
@@ -3684,7 +3684,7 @@
                 <a:latin typeface="Times New Roman" pitchFamily="18" charset="0"/>
                 <a:cs typeface="Times New Roman" pitchFamily="18" charset="0"/>
               </a:rPr>
-              <a:t>	    Second Review</a:t>
+              <a:t>	     Final Review </a:t>
             </a:r>
           </a:p>
           <a:p>
@@ -3697,7 +3697,7 @@
                 <a:latin typeface="Times New Roman" pitchFamily="18" charset="0"/>
                 <a:cs typeface="Times New Roman" pitchFamily="18" charset="0"/>
               </a:rPr>
-              <a:t>   Date: 2.7.2026  </a:t>
+              <a:t>Date: 2.7.2026  </a:t>
             </a:r>
           </a:p>
         </p:txBody>
@@ -3833,8 +3833,8 @@
         </p:nvSpPr>
         <p:spPr>
           <a:xfrm>
-            <a:off x="333417" y="690084"/>
-            <a:ext cx="8810583" cy="4214102"/>
+            <a:off x="254039" y="684917"/>
+            <a:ext cx="8810583" cy="4305089"/>
           </a:xfrm>
           <a:prstGeom prst="rect">
             <a:avLst/>
@@ -3871,14 +3871,35 @@
                 <a:latin typeface="Times New Roman" panose="02020603050405020304" pitchFamily="18" charset="0"/>
                 <a:cs typeface="Times New Roman" panose="02020603050405020304" pitchFamily="18" charset="0"/>
               </a:rPr>
-              <a:t>To design a full-stack gamified nursing education platform (React, Node.js, Express, SQLite) with role-based access control, interactive dashboards, and a comprehensive quiz management system.</a:t>
-            </a:r>
-            <a:r>
-              <a:rPr lang="en-GB" sz="1200" dirty="0">
+              <a:t>To design a full-stack gamified nursing education platform (</a:t>
+            </a:r>
+            <a:r>
+              <a:rPr lang="en-IN" sz="1200" b="1" dirty="0">
                 <a:latin typeface="Times New Roman" panose="02020603050405020304" pitchFamily="18" charset="0"/>
-                <a:cs typeface="Times New Roman" pitchFamily="18" charset="0"/>
+                <a:cs typeface="Times New Roman" panose="02020603050405020304" pitchFamily="18" charset="0"/>
               </a:rPr>
-              <a:t> </a:t>
+              <a:t>React, Node.js, Express, </a:t>
+            </a:r>
+            <a:r>
+              <a:rPr lang="en-IN" sz="1200" b="1" dirty="0" err="1">
+                <a:latin typeface="Times New Roman" panose="02020603050405020304" pitchFamily="18" charset="0"/>
+                <a:cs typeface="Times New Roman" panose="02020603050405020304" pitchFamily="18" charset="0"/>
+              </a:rPr>
+              <a:t>Supabase</a:t>
+            </a:r>
+            <a:r>
+              <a:rPr lang="en-IN" sz="1200" b="1" dirty="0">
+                <a:latin typeface="Times New Roman" panose="02020603050405020304" pitchFamily="18" charset="0"/>
+                <a:cs typeface="Times New Roman" panose="02020603050405020304" pitchFamily="18" charset="0"/>
+              </a:rPr>
+              <a:t> PostgreSQL</a:t>
+            </a:r>
+            <a:r>
+              <a:rPr lang="en-IN" sz="1200" dirty="0">
+                <a:latin typeface="Times New Roman" panose="02020603050405020304" pitchFamily="18" charset="0"/>
+                <a:cs typeface="Times New Roman" panose="02020603050405020304" pitchFamily="18" charset="0"/>
+              </a:rPr>
+              <a:t>) with role-based access control, interactive dashboards, and a comprehensive quiz management system.</a:t>
             </a:r>
           </a:p>
           <a:p>
@@ -3906,12 +3927,22 @@
                 <a:latin typeface="Times New Roman" panose="02020603050405020304" pitchFamily="18" charset="0"/>
                 <a:cs typeface="Times New Roman" panose="02020603050405020304" pitchFamily="18" charset="0"/>
               </a:rPr>
-              <a:t>To implement multimedia-rich question types — MCQ, image-based, video-based, audio-based, jumbled-letter, and sequence ordering — enabling varied and engaging assessments beyond traditional text-only quizzes.</a:t>
-            </a:r>
-            <a:endParaRPr lang="en-GB" sz="1200" dirty="0">
-              <a:latin typeface="Times New Roman" pitchFamily="18" charset="0"/>
-              <a:cs typeface="Times New Roman" pitchFamily="18" charset="0"/>
-            </a:endParaRPr>
+              <a:t>To implement </a:t>
+            </a:r>
+            <a:r>
+              <a:rPr lang="en-IN" sz="1200" b="1" dirty="0">
+                <a:latin typeface="Times New Roman" panose="02020603050405020304" pitchFamily="18" charset="0"/>
+                <a:cs typeface="Times New Roman" panose="02020603050405020304" pitchFamily="18" charset="0"/>
+              </a:rPr>
+              <a:t>9 interactive and multimedia-rich question types — including MCQ, image-based, video-based, audio-based, jumbled letters, sequence ordering, sliders, matching, and CAPTCHAs</a:t>
+            </a:r>
+            <a:r>
+              <a:rPr lang="en-IN" sz="1200" dirty="0">
+                <a:latin typeface="Times New Roman" panose="02020603050405020304" pitchFamily="18" charset="0"/>
+                <a:cs typeface="Times New Roman" panose="02020603050405020304" pitchFamily="18" charset="0"/>
+              </a:rPr>
+              <a:t> — enabling varied clinical assessments.</a:t>
+            </a:r>
           </a:p>
           <a:p>
             <a:pPr algn="just">
@@ -3921,7 +3952,7 @@
             </a:pPr>
             <a:r>
               <a:rPr lang="en-GB" sz="1200" dirty="0">
-                <a:latin typeface="Times New Roman" pitchFamily="18" charset="0"/>
+                <a:latin typeface="Times New Roman" panose="02020603050405020304" pitchFamily="18" charset="0"/>
                 <a:cs typeface="Times New Roman" pitchFamily="18" charset="0"/>
               </a:rPr>
               <a:t>Objective  - 3:</a:t>
@@ -3938,12 +3969,22 @@
                 <a:latin typeface="Times New Roman" panose="02020603050405020304" pitchFamily="18" charset="0"/>
                 <a:cs typeface="Times New Roman" panose="02020603050405020304" pitchFamily="18" charset="0"/>
               </a:rPr>
-              <a:t>To integrate nursing-specific learning features including categorized clinical quizzes, module-based organization, scenario-based assessments, and domain-relevant gamification (XP, levels, streaks, badges).</a:t>
-            </a:r>
-            <a:endParaRPr lang="en-GB" sz="1200" dirty="0">
-              <a:latin typeface="Times New Roman" pitchFamily="18" charset="0"/>
-              <a:cs typeface="Times New Roman" pitchFamily="18" charset="0"/>
-            </a:endParaRPr>
+              <a:t>To integrate nursing-specific learning features including categorized clinical quizzes, </a:t>
+            </a:r>
+            <a:r>
+              <a:rPr lang="en-IN" sz="1200" b="1" dirty="0">
+                <a:latin typeface="Times New Roman" panose="02020603050405020304" pitchFamily="18" charset="0"/>
+                <a:cs typeface="Times New Roman" panose="02020603050405020304" pitchFamily="18" charset="0"/>
+              </a:rPr>
+              <a:t>unit-based organization (Units 1 to 15)</a:t>
+            </a:r>
+            <a:r>
+              <a:rPr lang="en-IN" sz="1200" dirty="0">
+                <a:latin typeface="Times New Roman" panose="02020603050405020304" pitchFamily="18" charset="0"/>
+                <a:cs typeface="Times New Roman" panose="02020603050405020304" pitchFamily="18" charset="0"/>
+              </a:rPr>
+              <a:t>, scenario-based assessments, and domain-relevant gamification (XP, levels, streaks, badges).</a:t>
+            </a:r>
           </a:p>
           <a:p>
             <a:pPr algn="just">
@@ -3953,7 +3994,7 @@
             </a:pPr>
             <a:r>
               <a:rPr lang="en-GB" sz="1200" dirty="0">
-                <a:latin typeface="Times New Roman" pitchFamily="18" charset="0"/>
+                <a:latin typeface="Times New Roman" panose="02020603050405020304" pitchFamily="18" charset="0"/>
                 <a:cs typeface="Times New Roman" pitchFamily="18" charset="0"/>
               </a:rPr>
               <a:t>Objective  - 4:</a:t>
@@ -3972,10 +4013,6 @@
               </a:rPr>
               <a:t>To enable real-time multiplayer quiz sessions via Socket.IO with multi-device access, instant scoring, live leaderboards, and synchronized question delivery.</a:t>
             </a:r>
-            <a:endParaRPr lang="en-GB" sz="1200" dirty="0">
-              <a:latin typeface="Times New Roman" pitchFamily="18" charset="0"/>
-              <a:cs typeface="Times New Roman" pitchFamily="18" charset="0"/>
-            </a:endParaRPr>
           </a:p>
           <a:p>
             <a:pPr algn="just">
@@ -3985,7 +4022,7 @@
             </a:pPr>
             <a:r>
               <a:rPr lang="en-GB" sz="1200" dirty="0">
-                <a:latin typeface="Times New Roman" pitchFamily="18" charset="0"/>
+                <a:latin typeface="Times New Roman" panose="02020603050405020304" pitchFamily="18" charset="0"/>
                 <a:cs typeface="Times New Roman" pitchFamily="18" charset="0"/>
               </a:rPr>
               <a:t>Objective  - 5:</a:t>
@@ -4016,9 +4053,9 @@
                 <a:latin typeface="Times New Roman" panose="02020603050405020304" pitchFamily="18" charset="0"/>
                 <a:cs typeface="Times New Roman" panose="02020603050405020304" pitchFamily="18" charset="0"/>
               </a:rPr>
-              <a:t>, input validation), scalable single-server architecture, and real-world deployment</a:t>
-            </a:r>
-            <a:endParaRPr lang="en-GB" sz="1200" dirty="0">
+              <a:t>, input validation), scalable cloud architecture, and real-world deployment.</a:t>
+            </a:r>
+            <a:endParaRPr lang="en-GB" sz="1000" dirty="0">
               <a:latin typeface="Times New Roman" panose="02020603050405020304" pitchFamily="18" charset="0"/>
               <a:cs typeface="Times New Roman" pitchFamily="18" charset="0"/>
             </a:endParaRPr>
@@ -4042,7 +4079,7 @@
           <a:p>
             <a:fld id="{305CE664-CC6B-43B1-BCF8-14EAD95F037A}" type="datetime3">
               <a:rPr lang="en-US" smtClean="0"/>
-              <a:t>7 July 2026</a:t>
+              <a:t>10 July 2026</a:t>
             </a:fld>
             <a:endParaRPr lang="en-US" dirty="0"/>
           </a:p>
@@ -4206,7 +4243,7 @@
           <a:p>
             <a:fld id="{DE11E864-39B2-4D9A-938E-DF8E5B1FD578}" type="datetime3">
               <a:rPr lang="en-US" smtClean="0"/>
-              <a:t>7 July 2026</a:t>
+              <a:t>10 July 2026</a:t>
             </a:fld>
             <a:endParaRPr lang="en-US" dirty="0"/>
           </a:p>
@@ -4242,10 +4279,10 @@
       </p:sp>
       <p:pic>
         <p:nvPicPr>
-          <p:cNvPr id="8" name="Picture 7">
+          <p:cNvPr id="4" name="Picture 3">
             <a:extLst>
               <a:ext uri="{FF2B5EF4-FFF2-40B4-BE49-F238E27FC236}">
-                <a16:creationId xmlns:a16="http://schemas.microsoft.com/office/drawing/2014/main" id="{EC32B658-B339-B3DE-7453-42D51E87A3C0}"/>
+                <a16:creationId xmlns:a16="http://schemas.microsoft.com/office/drawing/2014/main" id="{583DEFE6-6416-904F-B0A0-FD487EB6AF98}"/>
               </a:ext>
             </a:extLst>
           </p:cNvPr>
@@ -4262,8 +4299,8 @@
         </p:blipFill>
         <p:spPr>
           <a:xfrm>
-            <a:off x="2159425" y="629128"/>
-            <a:ext cx="4825149" cy="4411980"/>
+            <a:off x="997616" y="554877"/>
+            <a:ext cx="7271013" cy="4349309"/>
           </a:xfrm>
           <a:prstGeom prst="rect">
             <a:avLst/>
@@ -4386,14 +4423,14 @@
           <p:nvPr>
             <p:extLst>
               <p:ext uri="{D42A27DB-BD31-4B8C-83A1-F6EECF244321}">
-                <p14:modId xmlns:p14="http://schemas.microsoft.com/office/powerpoint/2010/main" val="3402253326"/>
+                <p14:modId xmlns:p14="http://schemas.microsoft.com/office/powerpoint/2010/main" val="3907445099"/>
               </p:ext>
             </p:extLst>
           </p:nvPr>
         </p:nvGraphicFramePr>
         <p:xfrm>
-          <a:off x="628650" y="643109"/>
-          <a:ext cx="8313218" cy="3559607"/>
+          <a:off x="480447" y="643109"/>
+          <a:ext cx="8461421" cy="3918557"/>
         </p:xfrm>
         <a:graphic>
           <a:graphicData uri="http://schemas.openxmlformats.org/drawingml/2006/table">
@@ -4402,35 +4439,35 @@
                 <a:tableStyleId>{5940675A-B579-460E-94D1-54222C63F5DA}</a:tableStyleId>
               </a:tblPr>
               <a:tblGrid>
-                <a:gridCol w="342512">
+                <a:gridCol w="348618">
                   <a:extLst>
                     <a:ext uri="{9D8B030D-6E8A-4147-A177-3AD203B41FA5}">
                       <a16:colId xmlns:a16="http://schemas.microsoft.com/office/drawing/2014/main" val="20000"/>
                     </a:ext>
                   </a:extLst>
                 </a:gridCol>
-                <a:gridCol w="1416314">
+                <a:gridCol w="1441563">
                   <a:extLst>
                     <a:ext uri="{9D8B030D-6E8A-4147-A177-3AD203B41FA5}">
                       <a16:colId xmlns:a16="http://schemas.microsoft.com/office/drawing/2014/main" val="20001"/>
                     </a:ext>
                   </a:extLst>
                 </a:gridCol>
-                <a:gridCol w="2311230">
+                <a:gridCol w="2352433">
                   <a:extLst>
                     <a:ext uri="{9D8B030D-6E8A-4147-A177-3AD203B41FA5}">
                       <a16:colId xmlns:a16="http://schemas.microsoft.com/office/drawing/2014/main" val="20002"/>
                     </a:ext>
                   </a:extLst>
                 </a:gridCol>
-                <a:gridCol w="2352998">
+                <a:gridCol w="2394946">
                   <a:extLst>
                     <a:ext uri="{9D8B030D-6E8A-4147-A177-3AD203B41FA5}">
                       <a16:colId xmlns:a16="http://schemas.microsoft.com/office/drawing/2014/main" val="20003"/>
                     </a:ext>
                   </a:extLst>
                 </a:gridCol>
-                <a:gridCol w="1890164">
+                <a:gridCol w="1923861">
                   <a:extLst>
                     <a:ext uri="{9D8B030D-6E8A-4147-A177-3AD203B41FA5}">
                       <a16:colId xmlns:a16="http://schemas.microsoft.com/office/drawing/2014/main" val="20004"/>
@@ -4438,7 +4475,7 @@
                   </a:extLst>
                 </a:gridCol>
               </a:tblGrid>
-              <a:tr h="359207">
+              <a:tr h="416845">
                 <a:tc>
                   <a:txBody>
                     <a:bodyPr/>
@@ -4555,21 +4592,32 @@
                   </a:ext>
                 </a:extLst>
               </a:tr>
-              <a:tr h="388803">
-                <a:tc>
-                  <a:txBody>
-                    <a:bodyPr/>
-                    <a:lstStyle/>
-                    <a:p>
-                      <a:pPr>
+              <a:tr h="663203">
+                <a:tc>
+                  <a:txBody>
+                    <a:bodyPr/>
+                    <a:lstStyle/>
+                    <a:p>
+                      <a:pPr indent="0" algn="l">
                         <a:buNone/>
                       </a:pPr>
                       <a:r>
-                        <a:rPr lang="en-IN" sz="1200">
+                        <a:rPr lang="en-IN" sz="1050" b="1" i="0">
+                          <a:solidFill>
+                            <a:schemeClr val="tx1"/>
+                          </a:solidFill>
                           <a:effectLst/>
+                          <a:latin typeface="Segoe WPC"/>
                         </a:rPr>
                         <a:t>1</a:t>
                       </a:r>
+                      <a:endParaRPr lang="en-IN" sz="1050" b="0" i="0">
+                        <a:solidFill>
+                          <a:schemeClr val="tx1"/>
+                        </a:solidFill>
+                        <a:effectLst/>
+                        <a:latin typeface="Segoe WPC"/>
+                      </a:endParaRPr>
                     </a:p>
                   </a:txBody>
                   <a:tcPr anchor="ctr"/>
@@ -4579,18 +4627,28 @@
                     <a:bodyPr/>
                     <a:lstStyle/>
                     <a:p>
-                      <a:pPr>
+                      <a:pPr indent="0" algn="l">
                         <a:buNone/>
                       </a:pPr>
                       <a:r>
-                        <a:rPr lang="en-IN" sz="1200" b="1">
+                        <a:rPr lang="en-IN" sz="1050" b="1" i="0" dirty="0">
+                          <a:solidFill>
+                            <a:schemeClr val="tx1"/>
+                          </a:solidFill>
                           <a:effectLst/>
+                          <a:latin typeface="Times New Roman" panose="02020603050405020304" pitchFamily="18" charset="0"/>
+                          <a:cs typeface="Times New Roman" panose="02020603050405020304" pitchFamily="18" charset="0"/>
                         </a:rPr>
                         <a:t>Frontend Module</a:t>
                       </a:r>
                       <a:r>
-                        <a:rPr lang="en-IN" sz="1200">
+                        <a:rPr lang="en-IN" sz="1050" b="0" i="0" dirty="0">
+                          <a:solidFill>
+                            <a:schemeClr val="tx1"/>
+                          </a:solidFill>
                           <a:effectLst/>
+                          <a:latin typeface="Times New Roman" panose="02020603050405020304" pitchFamily="18" charset="0"/>
+                          <a:cs typeface="Times New Roman" panose="02020603050405020304" pitchFamily="18" charset="0"/>
                         </a:rPr>
                         <a:t> (UI Layer)</a:t>
                       </a:r>
@@ -4603,12 +4661,17 @@
                     <a:bodyPr/>
                     <a:lstStyle/>
                     <a:p>
-                      <a:pPr>
+                      <a:pPr indent="0" algn="l">
                         <a:buNone/>
                       </a:pPr>
                       <a:r>
-                        <a:rPr lang="en-IN" sz="1200">
+                        <a:rPr lang="en-IN" sz="1050" b="0" i="0">
+                          <a:solidFill>
+                            <a:schemeClr val="tx1"/>
+                          </a:solidFill>
                           <a:effectLst/>
+                          <a:latin typeface="Times New Roman" panose="02020603050405020304" pitchFamily="18" charset="0"/>
+                          <a:cs typeface="Times New Roman" panose="02020603050405020304" pitchFamily="18" charset="0"/>
                         </a:rPr>
                         <a:t>Component-based SPA; client-side routing; Context API state management</a:t>
                       </a:r>
@@ -4621,20 +4684,30 @@
                     <a:bodyPr/>
                     <a:lstStyle/>
                     <a:p>
-                      <a:pPr>
+                      <a:pPr indent="0" algn="l">
                         <a:buNone/>
                       </a:pPr>
                       <a:r>
-                        <a:rPr lang="en-IN" sz="1200" b="1" dirty="0">
+                        <a:rPr lang="en-IN" sz="1050" b="1" i="0">
+                          <a:solidFill>
+                            <a:schemeClr val="tx1"/>
+                          </a:solidFill>
                           <a:effectLst/>
+                          <a:latin typeface="Times New Roman" panose="02020603050405020304" pitchFamily="18" charset="0"/>
+                          <a:cs typeface="Times New Roman" panose="02020603050405020304" pitchFamily="18" charset="0"/>
                         </a:rPr>
                         <a:t>S/W:</a:t>
                       </a:r>
                       <a:r>
-                        <a:rPr lang="en-IN" sz="1200" dirty="0">
+                        <a:rPr lang="en-IN" sz="1050" b="0" i="0">
+                          <a:solidFill>
+                            <a:schemeClr val="tx1"/>
+                          </a:solidFill>
                           <a:effectLst/>
-                        </a:rPr>
-                        <a:t> React 19, Vite, React Router, Three.js, Lottie </a:t>
+                          <a:latin typeface="Times New Roman" panose="02020603050405020304" pitchFamily="18" charset="0"/>
+                          <a:cs typeface="Times New Roman" panose="02020603050405020304" pitchFamily="18" charset="0"/>
+                        </a:rPr>
+                        <a:t> React 19, Vite, React Router, Three.js, Lottie</a:t>
                       </a:r>
                     </a:p>
                   </a:txBody>
@@ -4645,14 +4718,30 @@
                     <a:bodyPr/>
                     <a:lstStyle/>
                     <a:p>
-                      <a:pPr>
+                      <a:pPr indent="0" algn="l">
                         <a:buNone/>
                       </a:pPr>
                       <a:r>
-                        <a:rPr lang="en-IN" sz="1200">
+                        <a:rPr lang="en-IN" sz="1050" b="1" i="0">
+                          <a:solidFill>
+                            <a:schemeClr val="tx1"/>
+                          </a:solidFill>
                           <a:effectLst/>
-                        </a:rPr>
-                        <a:t>11 pages, reusable components, 2 context providers, API client</a:t>
+                          <a:latin typeface="Times New Roman" panose="02020603050405020304" pitchFamily="18" charset="0"/>
+                          <a:cs typeface="Times New Roman" panose="02020603050405020304" pitchFamily="18" charset="0"/>
+                        </a:rPr>
+                        <a:t>14 pages</a:t>
+                      </a:r>
+                      <a:r>
+                        <a:rPr lang="en-IN" sz="1050" b="0" i="0">
+                          <a:solidFill>
+                            <a:schemeClr val="tx1"/>
+                          </a:solidFill>
+                          <a:effectLst/>
+                          <a:latin typeface="Times New Roman" panose="02020603050405020304" pitchFamily="18" charset="0"/>
+                          <a:cs typeface="Times New Roman" panose="02020603050405020304" pitchFamily="18" charset="0"/>
+                        </a:rPr>
+                        <a:t>, reusable components, 2 context providers, API client</a:t>
                       </a:r>
                     </a:p>
                   </a:txBody>
@@ -4664,21 +4753,32 @@
                   </a:ext>
                 </a:extLst>
               </a:tr>
-              <a:tr h="440029">
-                <a:tc>
-                  <a:txBody>
-                    <a:bodyPr/>
-                    <a:lstStyle/>
-                    <a:p>
-                      <a:pPr>
+              <a:tr h="663203">
+                <a:tc>
+                  <a:txBody>
+                    <a:bodyPr/>
+                    <a:lstStyle/>
+                    <a:p>
+                      <a:pPr indent="0" algn="l">
                         <a:buNone/>
                       </a:pPr>
                       <a:r>
-                        <a:rPr lang="en-IN" sz="1200">
+                        <a:rPr lang="en-IN" sz="1050" b="1" i="0">
+                          <a:solidFill>
+                            <a:schemeClr val="tx1"/>
+                          </a:solidFill>
                           <a:effectLst/>
+                          <a:latin typeface="Segoe WPC"/>
                         </a:rPr>
                         <a:t>2</a:t>
                       </a:r>
+                      <a:endParaRPr lang="en-IN" sz="1050" b="0" i="0">
+                        <a:solidFill>
+                          <a:schemeClr val="tx1"/>
+                        </a:solidFill>
+                        <a:effectLst/>
+                        <a:latin typeface="Segoe WPC"/>
+                      </a:endParaRPr>
                     </a:p>
                   </a:txBody>
                   <a:tcPr anchor="ctr"/>
@@ -4688,18 +4788,28 @@
                     <a:bodyPr/>
                     <a:lstStyle/>
                     <a:p>
-                      <a:pPr>
+                      <a:pPr indent="0" algn="l">
                         <a:buNone/>
                       </a:pPr>
                       <a:r>
-                        <a:rPr lang="en-IN" sz="1200" b="1">
+                        <a:rPr lang="en-IN" sz="1050" b="1" i="0">
+                          <a:solidFill>
+                            <a:schemeClr val="tx1"/>
+                          </a:solidFill>
                           <a:effectLst/>
+                          <a:latin typeface="Times New Roman" panose="02020603050405020304" pitchFamily="18" charset="0"/>
+                          <a:cs typeface="Times New Roman" panose="02020603050405020304" pitchFamily="18" charset="0"/>
                         </a:rPr>
                         <a:t>Backend API Module</a:t>
                       </a:r>
                       <a:r>
-                        <a:rPr lang="en-IN" sz="1200">
+                        <a:rPr lang="en-IN" sz="1050" b="0" i="0">
+                          <a:solidFill>
+                            <a:schemeClr val="tx1"/>
+                          </a:solidFill>
                           <a:effectLst/>
+                          <a:latin typeface="Times New Roman" panose="02020603050405020304" pitchFamily="18" charset="0"/>
+                          <a:cs typeface="Times New Roman" panose="02020603050405020304" pitchFamily="18" charset="0"/>
                         </a:rPr>
                         <a:t> (Server Layer)</a:t>
                       </a:r>
@@ -4712,12 +4822,17 @@
                     <a:bodyPr/>
                     <a:lstStyle/>
                     <a:p>
-                      <a:pPr>
+                      <a:pPr indent="0" algn="l">
                         <a:buNone/>
                       </a:pPr>
                       <a:r>
-                        <a:rPr lang="en-IN" sz="1200">
+                        <a:rPr lang="en-IN" sz="1050" b="0" i="0" dirty="0">
+                          <a:solidFill>
+                            <a:schemeClr val="tx1"/>
+                          </a:solidFill>
                           <a:effectLst/>
+                          <a:latin typeface="Times New Roman" panose="02020603050405020304" pitchFamily="18" charset="0"/>
+                          <a:cs typeface="Times New Roman" panose="02020603050405020304" pitchFamily="18" charset="0"/>
                         </a:rPr>
                         <a:t>RESTful API; MVC pattern; middleware chaining; MIME-filtered uploads</a:t>
                       </a:r>
@@ -4730,44 +4845,30 @@
                     <a:bodyPr/>
                     <a:lstStyle/>
                     <a:p>
-                      <a:pPr>
+                      <a:pPr indent="0" algn="l">
                         <a:buNone/>
                       </a:pPr>
                       <a:r>
-                        <a:rPr lang="en-IN" sz="1200" b="1" dirty="0">
+                        <a:rPr lang="en-IN" sz="1050" b="1" i="0">
+                          <a:solidFill>
+                            <a:schemeClr val="tx1"/>
+                          </a:solidFill>
                           <a:effectLst/>
+                          <a:latin typeface="Times New Roman" panose="02020603050405020304" pitchFamily="18" charset="0"/>
+                          <a:cs typeface="Times New Roman" panose="02020603050405020304" pitchFamily="18" charset="0"/>
                         </a:rPr>
                         <a:t>S/W:</a:t>
                       </a:r>
                       <a:r>
-                        <a:rPr lang="en-IN" sz="1200" dirty="0">
+                        <a:rPr lang="en-IN" sz="1050" b="0" i="0">
+                          <a:solidFill>
+                            <a:schemeClr val="tx1"/>
+                          </a:solidFill>
                           <a:effectLst/>
-                        </a:rPr>
-                        <a:t> Node.js, Express 5, Multer, CORS</a:t>
-                      </a:r>
-                      <a:r>
-                        <a:rPr lang="en-IN" sz="1200" b="1" dirty="0">
-                          <a:effectLst/>
-                        </a:rPr>
-                        <a:t> </a:t>
-                      </a:r>
-                      <a:r>
-                        <a:rPr lang="en-IN" sz="1200" b="0" dirty="0">
-                          <a:effectLst/>
-                        </a:rPr>
-                        <a:t>with</a:t>
-                      </a:r>
-                      <a:r>
-                        <a:rPr lang="en-IN" sz="1200" b="1" dirty="0">
-                          <a:effectLst/>
-                        </a:rPr>
-                        <a:t> </a:t>
-                      </a:r>
-                      <a:r>
-                        <a:rPr lang="en-IN" sz="1200" dirty="0">
-                          <a:effectLst/>
-                        </a:rPr>
-                        <a:t>Node.js 18+ server</a:t>
+                          <a:latin typeface="Times New Roman" panose="02020603050405020304" pitchFamily="18" charset="0"/>
+                          <a:cs typeface="Times New Roman" panose="02020603050405020304" pitchFamily="18" charset="0"/>
+                        </a:rPr>
+                        <a:t> Node.js, Express 5, Multer, CORS with Node.js 18+ server</a:t>
                       </a:r>
                     </a:p>
                   </a:txBody>
@@ -4778,14 +4879,30 @@
                     <a:bodyPr/>
                     <a:lstStyle/>
                     <a:p>
-                      <a:pPr>
+                      <a:pPr indent="0" algn="l">
                         <a:buNone/>
                       </a:pPr>
                       <a:r>
-                        <a:rPr lang="en-IN" sz="1200">
+                        <a:rPr lang="en-IN" sz="1050" b="1" i="0">
+                          <a:solidFill>
+                            <a:schemeClr val="tx1"/>
+                          </a:solidFill>
                           <a:effectLst/>
-                        </a:rPr>
-                        <a:t>5 route modules, file upload endpoint, media handler</a:t>
+                          <a:latin typeface="Times New Roman" panose="02020603050405020304" pitchFamily="18" charset="0"/>
+                          <a:cs typeface="Times New Roman" panose="02020603050405020304" pitchFamily="18" charset="0"/>
+                        </a:rPr>
+                        <a:t>6 route modules</a:t>
+                      </a:r>
+                      <a:r>
+                        <a:rPr lang="en-IN" sz="1050" b="0" i="0">
+                          <a:solidFill>
+                            <a:schemeClr val="tx1"/>
+                          </a:solidFill>
+                          <a:effectLst/>
+                          <a:latin typeface="Times New Roman" panose="02020603050405020304" pitchFamily="18" charset="0"/>
+                          <a:cs typeface="Times New Roman" panose="02020603050405020304" pitchFamily="18" charset="0"/>
+                        </a:rPr>
+                        <a:t>, file upload endpoint, media handler</a:t>
                       </a:r>
                     </a:p>
                   </a:txBody>
@@ -4797,21 +4914,32 @@
                   </a:ext>
                 </a:extLst>
               </a:tr>
-              <a:tr h="491779">
-                <a:tc>
-                  <a:txBody>
-                    <a:bodyPr/>
-                    <a:lstStyle/>
-                    <a:p>
-                      <a:pPr>
+              <a:tr h="663203">
+                <a:tc>
+                  <a:txBody>
+                    <a:bodyPr/>
+                    <a:lstStyle/>
+                    <a:p>
+                      <a:pPr indent="0" algn="l">
                         <a:buNone/>
                       </a:pPr>
                       <a:r>
-                        <a:rPr lang="en-IN" sz="1200">
+                        <a:rPr lang="en-IN" sz="1050" b="1" i="0">
+                          <a:solidFill>
+                            <a:schemeClr val="tx1"/>
+                          </a:solidFill>
                           <a:effectLst/>
+                          <a:latin typeface="Segoe WPC"/>
                         </a:rPr>
                         <a:t>3</a:t>
                       </a:r>
+                      <a:endParaRPr lang="en-IN" sz="1050" b="0" i="0">
+                        <a:solidFill>
+                          <a:schemeClr val="tx1"/>
+                        </a:solidFill>
+                        <a:effectLst/>
+                        <a:latin typeface="Segoe WPC"/>
+                      </a:endParaRPr>
                     </a:p>
                   </a:txBody>
                   <a:tcPr anchor="ctr"/>
@@ -4821,18 +4949,28 @@
                     <a:bodyPr/>
                     <a:lstStyle/>
                     <a:p>
-                      <a:pPr>
+                      <a:pPr indent="0" algn="l">
                         <a:buNone/>
                       </a:pPr>
                       <a:r>
-                        <a:rPr lang="en-IN" sz="1200" b="1">
+                        <a:rPr lang="en-IN" sz="1050" b="1" i="0">
+                          <a:solidFill>
+                            <a:schemeClr val="tx1"/>
+                          </a:solidFill>
                           <a:effectLst/>
+                          <a:latin typeface="Times New Roman" panose="02020603050405020304" pitchFamily="18" charset="0"/>
+                          <a:cs typeface="Times New Roman" panose="02020603050405020304" pitchFamily="18" charset="0"/>
                         </a:rPr>
                         <a:t>Auth Module</a:t>
                       </a:r>
                       <a:r>
-                        <a:rPr lang="en-IN" sz="1200">
+                        <a:rPr lang="en-IN" sz="1050" b="0" i="0">
+                          <a:solidFill>
+                            <a:schemeClr val="tx1"/>
+                          </a:solidFill>
                           <a:effectLst/>
+                          <a:latin typeface="Times New Roman" panose="02020603050405020304" pitchFamily="18" charset="0"/>
+                          <a:cs typeface="Times New Roman" panose="02020603050405020304" pitchFamily="18" charset="0"/>
                         </a:rPr>
                         <a:t> (Security Layer)</a:t>
                       </a:r>
@@ -4845,14 +4983,74 @@
                     <a:bodyPr/>
                     <a:lstStyle/>
                     <a:p>
-                      <a:pPr>
+                      <a:pPr indent="0" algn="l">
                         <a:buNone/>
                       </a:pPr>
                       <a:r>
-                        <a:rPr lang="en-IN" sz="1200">
+                        <a:rPr lang="en-IN" sz="1050" b="0" i="0" dirty="0">
+                          <a:solidFill>
+                            <a:schemeClr val="tx1"/>
+                          </a:solidFill>
                           <a:effectLst/>
-                        </a:rPr>
-                        <a:t>JWT token auth; bcrypt hashing (salt=10); role-based access control</a:t>
+                          <a:latin typeface="Times New Roman" panose="02020603050405020304" pitchFamily="18" charset="0"/>
+                          <a:cs typeface="Times New Roman" panose="02020603050405020304" pitchFamily="18" charset="0"/>
+                        </a:rPr>
+                        <a:t>JWT token auth; </a:t>
+                      </a:r>
+                      <a:r>
+                        <a:rPr lang="en-IN" sz="1050" b="1" i="0" dirty="0" err="1">
+                          <a:solidFill>
+                            <a:schemeClr val="tx1"/>
+                          </a:solidFill>
+                          <a:effectLst/>
+                          <a:latin typeface="Times New Roman" panose="02020603050405020304" pitchFamily="18" charset="0"/>
+                          <a:cs typeface="Times New Roman" panose="02020603050405020304" pitchFamily="18" charset="0"/>
+                        </a:rPr>
+                        <a:t>Supabase</a:t>
+                      </a:r>
+                      <a:r>
+                        <a:rPr lang="en-IN" sz="1050" b="1" i="0" dirty="0">
+                          <a:solidFill>
+                            <a:schemeClr val="tx1"/>
+                          </a:solidFill>
+                          <a:effectLst/>
+                          <a:latin typeface="Times New Roman" panose="02020603050405020304" pitchFamily="18" charset="0"/>
+                          <a:cs typeface="Times New Roman" panose="02020603050405020304" pitchFamily="18" charset="0"/>
+                        </a:rPr>
+                        <a:t> Auth (</a:t>
+                      </a:r>
+                      <a:r>
+                        <a:rPr lang="en-IN" sz="1050" b="1" i="0" dirty="0" err="1">
+                          <a:solidFill>
+                            <a:schemeClr val="tx1"/>
+                          </a:solidFill>
+                          <a:effectLst/>
+                          <a:latin typeface="Times New Roman" panose="02020603050405020304" pitchFamily="18" charset="0"/>
+                          <a:cs typeface="Times New Roman" panose="02020603050405020304" pitchFamily="18" charset="0"/>
+                        </a:rPr>
+                        <a:t>GoTrue</a:t>
+                      </a:r>
+                      <a:r>
+                        <a:rPr lang="en-IN" sz="1050" b="1" i="0" dirty="0">
+                          <a:solidFill>
+                            <a:schemeClr val="tx1"/>
+                          </a:solidFill>
+                          <a:effectLst/>
+                          <a:latin typeface="Times New Roman" panose="02020603050405020304" pitchFamily="18" charset="0"/>
+                          <a:cs typeface="Times New Roman" panose="02020603050405020304" pitchFamily="18" charset="0"/>
+                        </a:rPr>
+                        <a:t>)</a:t>
+                      </a:r>
+                      <a:r>
+                        <a:rPr lang="en-IN" sz="1050" b="0" i="0" dirty="0">
+                          <a:solidFill>
+                            <a:schemeClr val="tx1"/>
+                          </a:solidFill>
+                          <a:effectLst/>
+                          <a:latin typeface="Times New Roman" panose="02020603050405020304" pitchFamily="18" charset="0"/>
+                          <a:cs typeface="Times New Roman" panose="02020603050405020304" pitchFamily="18" charset="0"/>
+                        </a:rPr>
+                        <a:t> integration; role-based access control</a:t>
                       </a:r>
                     </a:p>
                   </a:txBody>
@@ -4863,42 +5061,83 @@
                     <a:bodyPr/>
                     <a:lstStyle/>
                     <a:p>
-                      <a:pPr>
+                      <a:pPr indent="0" algn="l">
                         <a:buNone/>
                       </a:pPr>
                       <a:r>
-                        <a:rPr lang="en-IN" sz="1200" b="1" dirty="0">
+                        <a:rPr lang="en-IN" sz="1050" b="1" i="0" dirty="0">
+                          <a:solidFill>
+                            <a:schemeClr val="tx1"/>
+                          </a:solidFill>
                           <a:effectLst/>
+                          <a:latin typeface="Times New Roman" panose="02020603050405020304" pitchFamily="18" charset="0"/>
+                          <a:cs typeface="Times New Roman" panose="02020603050405020304" pitchFamily="18" charset="0"/>
                         </a:rPr>
                         <a:t>S/W:</a:t>
                       </a:r>
                       <a:r>
-                        <a:rPr lang="en-IN" sz="1200" dirty="0">
+                        <a:rPr lang="en-IN" sz="1050" b="0" i="0" dirty="0">
+                          <a:solidFill>
+                            <a:schemeClr val="tx1"/>
+                          </a:solidFill>
                           <a:effectLst/>
+                          <a:latin typeface="Times New Roman" panose="02020603050405020304" pitchFamily="18" charset="0"/>
+                          <a:cs typeface="Times New Roman" panose="02020603050405020304" pitchFamily="18" charset="0"/>
                         </a:rPr>
                         <a:t> </a:t>
                       </a:r>
                       <a:r>
-                        <a:rPr lang="en-IN" sz="1200" dirty="0" err="1">
+                        <a:rPr lang="en-IN" sz="1050" b="0" i="0" dirty="0" err="1">
+                          <a:solidFill>
+                            <a:schemeClr val="tx1"/>
+                          </a:solidFill>
                           <a:effectLst/>
+                          <a:latin typeface="Times New Roman" panose="02020603050405020304" pitchFamily="18" charset="0"/>
+                          <a:cs typeface="Times New Roman" panose="02020603050405020304" pitchFamily="18" charset="0"/>
                         </a:rPr>
                         <a:t>jsonwebtoken</a:t>
                       </a:r>
                       <a:r>
-                        <a:rPr lang="en-IN" sz="1200" dirty="0">
+                        <a:rPr lang="en-IN" sz="1050" b="0" i="0" dirty="0">
+                          <a:solidFill>
+                            <a:schemeClr val="tx1"/>
+                          </a:solidFill>
                           <a:effectLst/>
-                        </a:rPr>
-                        <a:t>, </a:t>
-                      </a:r>
-                      <a:r>
-                        <a:rPr lang="en-IN" sz="1200" dirty="0" err="1">
+                          <a:latin typeface="Times New Roman" panose="02020603050405020304" pitchFamily="18" charset="0"/>
+                          <a:cs typeface="Times New Roman" panose="02020603050405020304" pitchFamily="18" charset="0"/>
+                        </a:rPr>
+                        <a:t>, </a:t>
+                      </a:r>
+                      <a:r>
+                        <a:rPr lang="en-IN" sz="1050" b="1" i="0" dirty="0" err="1">
+                          <a:solidFill>
+                            <a:schemeClr val="tx1"/>
+                          </a:solidFill>
                           <a:effectLst/>
-                        </a:rPr>
-                        <a:t>bcryptjs</a:t>
-                      </a:r>
-                      <a:r>
-                        <a:rPr lang="en-IN" sz="1200" dirty="0">
+                          <a:latin typeface="Times New Roman" panose="02020603050405020304" pitchFamily="18" charset="0"/>
+                          <a:cs typeface="Times New Roman" panose="02020603050405020304" pitchFamily="18" charset="0"/>
+                        </a:rPr>
+                        <a:t>Supabase</a:t>
+                      </a:r>
+                      <a:r>
+                        <a:rPr lang="en-IN" sz="1050" b="1" i="0" dirty="0">
+                          <a:solidFill>
+                            <a:schemeClr val="tx1"/>
+                          </a:solidFill>
                           <a:effectLst/>
+                          <a:latin typeface="Times New Roman" panose="02020603050405020304" pitchFamily="18" charset="0"/>
+                          <a:cs typeface="Times New Roman" panose="02020603050405020304" pitchFamily="18" charset="0"/>
+                        </a:rPr>
+                        <a:t> Auth</a:t>
+                      </a:r>
+                      <a:r>
+                        <a:rPr lang="en-IN" sz="1050" b="0" i="0" dirty="0">
+                          <a:solidFill>
+                            <a:schemeClr val="tx1"/>
+                          </a:solidFill>
+                          <a:effectLst/>
+                          <a:latin typeface="Times New Roman" panose="02020603050405020304" pitchFamily="18" charset="0"/>
+                          <a:cs typeface="Times New Roman" panose="02020603050405020304" pitchFamily="18" charset="0"/>
                         </a:rPr>
                         <a:t>, Express middleware</a:t>
                       </a:r>
@@ -4911,14 +5150,19 @@
                     <a:bodyPr/>
                     <a:lstStyle/>
                     <a:p>
-                      <a:pPr>
+                      <a:pPr indent="0" algn="l">
                         <a:buNone/>
                       </a:pPr>
                       <a:r>
-                        <a:rPr lang="en-IN" sz="1200" dirty="0">
+                        <a:rPr lang="en-IN" sz="1050" b="0" i="0">
+                          <a:solidFill>
+                            <a:schemeClr val="tx1"/>
+                          </a:solidFill>
                           <a:effectLst/>
-                        </a:rPr>
-                        <a:t>Token sign/verify, password hashing, role-gating middleware</a:t>
+                          <a:latin typeface="Times New Roman" panose="02020603050405020304" pitchFamily="18" charset="0"/>
+                          <a:cs typeface="Times New Roman" panose="02020603050405020304" pitchFamily="18" charset="0"/>
+                        </a:rPr>
+                        <a:t>Token sign/verify, user management, role-gating middleware</a:t>
                       </a:r>
                     </a:p>
                   </a:txBody>
@@ -4930,21 +5174,32 @@
                   </a:ext>
                 </a:extLst>
               </a:tr>
-              <a:tr h="440029">
-                <a:tc>
-                  <a:txBody>
-                    <a:bodyPr/>
-                    <a:lstStyle/>
-                    <a:p>
-                      <a:pPr>
+              <a:tr h="848900">
+                <a:tc>
+                  <a:txBody>
+                    <a:bodyPr/>
+                    <a:lstStyle/>
+                    <a:p>
+                      <a:pPr indent="0" algn="l">
                         <a:buNone/>
                       </a:pPr>
                       <a:r>
-                        <a:rPr lang="en-IN" sz="1200" dirty="0">
+                        <a:rPr lang="en-IN" sz="1050" b="1" i="0">
+                          <a:solidFill>
+                            <a:schemeClr val="tx1"/>
+                          </a:solidFill>
                           <a:effectLst/>
+                          <a:latin typeface="Segoe WPC"/>
                         </a:rPr>
                         <a:t>4</a:t>
                       </a:r>
+                      <a:endParaRPr lang="en-IN" sz="1050" b="0" i="0">
+                        <a:solidFill>
+                          <a:schemeClr val="tx1"/>
+                        </a:solidFill>
+                        <a:effectLst/>
+                        <a:latin typeface="Segoe WPC"/>
+                      </a:endParaRPr>
                     </a:p>
                   </a:txBody>
                   <a:tcPr anchor="ctr"/>
@@ -4954,18 +5209,28 @@
                     <a:bodyPr/>
                     <a:lstStyle/>
                     <a:p>
-                      <a:pPr>
+                      <a:pPr indent="0" algn="l">
                         <a:buNone/>
                       </a:pPr>
                       <a:r>
-                        <a:rPr lang="en-IN" sz="1200" b="1">
+                        <a:rPr lang="en-IN" sz="1050" b="1" i="0">
+                          <a:solidFill>
+                            <a:schemeClr val="tx1"/>
+                          </a:solidFill>
                           <a:effectLst/>
+                          <a:latin typeface="Times New Roman" panose="02020603050405020304" pitchFamily="18" charset="0"/>
+                          <a:cs typeface="Times New Roman" panose="02020603050405020304" pitchFamily="18" charset="0"/>
                         </a:rPr>
                         <a:t>Database Module</a:t>
                       </a:r>
                       <a:r>
-                        <a:rPr lang="en-IN" sz="1200">
+                        <a:rPr lang="en-IN" sz="1050" b="0" i="0">
+                          <a:solidFill>
+                            <a:schemeClr val="tx1"/>
+                          </a:solidFill>
                           <a:effectLst/>
+                          <a:latin typeface="Times New Roman" panose="02020603050405020304" pitchFamily="18" charset="0"/>
+                          <a:cs typeface="Times New Roman" panose="02020603050405020304" pitchFamily="18" charset="0"/>
                         </a:rPr>
                         <a:t> (Data Layer)</a:t>
                       </a:r>
@@ -4978,15 +5243,39 @@
                     <a:bodyPr/>
                     <a:lstStyle/>
                     <a:p>
-                      <a:pPr>
+                      <a:pPr indent="0" algn="l">
                         <a:buNone/>
                       </a:pPr>
                       <a:r>
-                        <a:rPr lang="en-IN" sz="1200">
+                        <a:rPr lang="en-IN" sz="1050" b="0" i="0">
+                          <a:solidFill>
+                            <a:schemeClr val="tx1"/>
+                          </a:solidFill>
                           <a:effectLst/>
-                        </a:rPr>
-                        <a:t>Relational schema; prepared statements; WAL journaling; auto-migration</a:t>
-                      </a:r>
+                          <a:latin typeface="Times New Roman" panose="02020603050405020304" pitchFamily="18" charset="0"/>
+                          <a:cs typeface="Times New Roman" panose="02020603050405020304" pitchFamily="18" charset="0"/>
+                        </a:rPr>
+                        <a:t>PostgreSQL relational schema; connection pooling; </a:t>
+                      </a:r>
+                      <a:r>
+                        <a:rPr lang="en-IN" sz="1050" b="1" i="0">
+                          <a:solidFill>
+                            <a:schemeClr val="tx1"/>
+                          </a:solidFill>
+                          <a:effectLst/>
+                          <a:latin typeface="Times New Roman" panose="02020603050405020304" pitchFamily="18" charset="0"/>
+                          <a:cs typeface="Times New Roman" panose="02020603050405020304" pitchFamily="18" charset="0"/>
+                        </a:rPr>
+                        <a:t>Supabase trigger-based user sync</a:t>
+                      </a:r>
+                      <a:endParaRPr lang="en-IN" sz="1050" b="0" i="0">
+                        <a:solidFill>
+                          <a:schemeClr val="tx1"/>
+                        </a:solidFill>
+                        <a:effectLst/>
+                        <a:latin typeface="Times New Roman" panose="02020603050405020304" pitchFamily="18" charset="0"/>
+                        <a:cs typeface="Times New Roman" panose="02020603050405020304" pitchFamily="18" charset="0"/>
+                      </a:endParaRPr>
                     </a:p>
                   </a:txBody>
                   <a:tcPr anchor="ctr"/>
@@ -4996,33 +5285,137 @@
                     <a:bodyPr/>
                     <a:lstStyle/>
                     <a:p>
-                      <a:pPr>
+                      <a:pPr indent="0" algn="l">
                         <a:buNone/>
                       </a:pPr>
                       <a:r>
-                        <a:rPr lang="en-IN" sz="1200" b="1">
+                        <a:rPr lang="en-IN" sz="1050" b="1" i="0" dirty="0">
+                          <a:solidFill>
+                            <a:schemeClr val="tx1"/>
+                          </a:solidFill>
                           <a:effectLst/>
+                          <a:latin typeface="Times New Roman" panose="02020603050405020304" pitchFamily="18" charset="0"/>
+                          <a:cs typeface="Times New Roman" panose="02020603050405020304" pitchFamily="18" charset="0"/>
                         </a:rPr>
                         <a:t>S/W:</a:t>
                       </a:r>
                       <a:r>
-                        <a:rPr lang="en-IN" sz="1200">
+                        <a:rPr lang="en-IN" sz="1050" b="0" i="0" dirty="0">
+                          <a:solidFill>
+                            <a:schemeClr val="tx1"/>
+                          </a:solidFill>
                           <a:effectLst/>
-                        </a:rPr>
-                        <a:t> SQLite, better-sqlite3, UUID </a:t>
-                      </a:r>
-                      <a:r>
-                        <a:rPr lang="en-IN" sz="1200" b="1">
+                          <a:latin typeface="Times New Roman" panose="02020603050405020304" pitchFamily="18" charset="0"/>
+                          <a:cs typeface="Times New Roman" panose="02020603050405020304" pitchFamily="18" charset="0"/>
+                        </a:rPr>
+                        <a:t> </a:t>
+                      </a:r>
+                      <a:r>
+                        <a:rPr lang="en-IN" sz="1050" b="1" i="0" dirty="0" err="1">
+                          <a:solidFill>
+                            <a:schemeClr val="tx1"/>
+                          </a:solidFill>
                           <a:effectLst/>
+                          <a:latin typeface="Times New Roman" panose="02020603050405020304" pitchFamily="18" charset="0"/>
+                          <a:cs typeface="Times New Roman" panose="02020603050405020304" pitchFamily="18" charset="0"/>
+                        </a:rPr>
+                        <a:t>Supabase</a:t>
+                      </a:r>
+                      <a:r>
+                        <a:rPr lang="en-IN" sz="1050" b="1" i="0" dirty="0">
+                          <a:solidFill>
+                            <a:schemeClr val="tx1"/>
+                          </a:solidFill>
+                          <a:effectLst/>
+                          <a:latin typeface="Times New Roman" panose="02020603050405020304" pitchFamily="18" charset="0"/>
+                          <a:cs typeface="Times New Roman" panose="02020603050405020304" pitchFamily="18" charset="0"/>
+                        </a:rPr>
+                        <a:t> (PostgreSQL), </a:t>
+                      </a:r>
+                      <a:r>
+                        <a:rPr lang="en-IN" sz="1050" b="1" i="0" dirty="0" err="1">
+                          <a:solidFill>
+                            <a:schemeClr val="tx1"/>
+                          </a:solidFill>
+                          <a:effectLst/>
+                          <a:latin typeface="Times New Roman" panose="02020603050405020304" pitchFamily="18" charset="0"/>
+                          <a:cs typeface="Times New Roman" panose="02020603050405020304" pitchFamily="18" charset="0"/>
+                        </a:rPr>
+                        <a:t>postgres</a:t>
+                      </a:r>
+                      <a:r>
+                        <a:rPr lang="en-IN" sz="1050" b="1" i="0" dirty="0">
+                          <a:solidFill>
+                            <a:schemeClr val="tx1"/>
+                          </a:solidFill>
+                          <a:effectLst/>
+                          <a:latin typeface="Times New Roman" panose="02020603050405020304" pitchFamily="18" charset="0"/>
+                          <a:cs typeface="Times New Roman" panose="02020603050405020304" pitchFamily="18" charset="0"/>
+                        </a:rPr>
+                        <a:t> driver</a:t>
+                      </a:r>
+                      <a:br>
+                        <a:rPr lang="en-IN" sz="1050" b="0" i="0" dirty="0">
+                          <a:solidFill>
+                            <a:schemeClr val="tx1"/>
+                          </a:solidFill>
+                          <a:effectLst/>
+                          <a:latin typeface="Times New Roman" panose="02020603050405020304" pitchFamily="18" charset="0"/>
+                          <a:cs typeface="Times New Roman" panose="02020603050405020304" pitchFamily="18" charset="0"/>
+                        </a:rPr>
+                      </a:br>
+                      <a:r>
+                        <a:rPr lang="en-IN" sz="1050" b="1" i="0" dirty="0">
+                          <a:solidFill>
+                            <a:schemeClr val="tx1"/>
+                          </a:solidFill>
+                          <a:effectLst/>
+                          <a:latin typeface="Times New Roman" panose="02020603050405020304" pitchFamily="18" charset="0"/>
+                          <a:cs typeface="Times New Roman" panose="02020603050405020304" pitchFamily="18" charset="0"/>
                         </a:rPr>
                         <a:t>H/W:</a:t>
                       </a:r>
                       <a:r>
-                        <a:rPr lang="en-IN" sz="1200">
+                        <a:rPr lang="en-IN" sz="1050" b="0" i="0" dirty="0">
+                          <a:solidFill>
+                            <a:schemeClr val="tx1"/>
+                          </a:solidFill>
                           <a:effectLst/>
-                        </a:rPr>
-                        <a:t> Local file storage</a:t>
-                      </a:r>
+                          <a:latin typeface="Times New Roman" panose="02020603050405020304" pitchFamily="18" charset="0"/>
+                          <a:cs typeface="Times New Roman" panose="02020603050405020304" pitchFamily="18" charset="0"/>
+                        </a:rPr>
+                        <a:t> </a:t>
+                      </a:r>
+                      <a:r>
+                        <a:rPr lang="en-IN" sz="1050" b="1" i="0" dirty="0" err="1">
+                          <a:solidFill>
+                            <a:schemeClr val="tx1"/>
+                          </a:solidFill>
+                          <a:effectLst/>
+                          <a:latin typeface="Times New Roman" panose="02020603050405020304" pitchFamily="18" charset="0"/>
+                          <a:cs typeface="Times New Roman" panose="02020603050405020304" pitchFamily="18" charset="0"/>
+                        </a:rPr>
+                        <a:t>Supabase</a:t>
+                      </a:r>
+                      <a:r>
+                        <a:rPr lang="en-IN" sz="1050" b="1" i="0" dirty="0">
+                          <a:solidFill>
+                            <a:schemeClr val="tx1"/>
+                          </a:solidFill>
+                          <a:effectLst/>
+                          <a:latin typeface="Times New Roman" panose="02020603050405020304" pitchFamily="18" charset="0"/>
+                          <a:cs typeface="Times New Roman" panose="02020603050405020304" pitchFamily="18" charset="0"/>
+                        </a:rPr>
+                        <a:t> Cloud (AWS Hosted)</a:t>
+                      </a:r>
+                      <a:endParaRPr lang="en-IN" sz="1050" b="0" i="0" dirty="0">
+                        <a:solidFill>
+                          <a:schemeClr val="tx1"/>
+                        </a:solidFill>
+                        <a:effectLst/>
+                        <a:latin typeface="Times New Roman" panose="02020603050405020304" pitchFamily="18" charset="0"/>
+                        <a:cs typeface="Times New Roman" panose="02020603050405020304" pitchFamily="18" charset="0"/>
+                      </a:endParaRPr>
                     </a:p>
                   </a:txBody>
                   <a:tcPr anchor="ctr"/>
@@ -5032,14 +5425,52 @@
                     <a:bodyPr/>
                     <a:lstStyle/>
                     <a:p>
-                      <a:pPr>
+                      <a:pPr indent="0" algn="l">
                         <a:buNone/>
                       </a:pPr>
                       <a:r>
-                        <a:rPr lang="en-IN" sz="1200">
+                        <a:rPr lang="en-IN" sz="1050" b="1" i="0" dirty="0">
+                          <a:solidFill>
+                            <a:schemeClr val="tx1"/>
+                          </a:solidFill>
                           <a:effectLst/>
-                        </a:rPr>
-                        <a:t>6 tables, schema.sql, init.js with migrations, seed.js</a:t>
+                          <a:latin typeface="Times New Roman" panose="02020603050405020304" pitchFamily="18" charset="0"/>
+                          <a:cs typeface="Times New Roman" panose="02020603050405020304" pitchFamily="18" charset="0"/>
+                        </a:rPr>
+                        <a:t>11 tables</a:t>
+                      </a:r>
+                      <a:r>
+                        <a:rPr lang="en-IN" sz="1050" b="0" i="0" dirty="0">
+                          <a:solidFill>
+                            <a:schemeClr val="tx1"/>
+                          </a:solidFill>
+                          <a:effectLst/>
+                          <a:latin typeface="Times New Roman" panose="02020603050405020304" pitchFamily="18" charset="0"/>
+                          <a:cs typeface="Times New Roman" panose="02020603050405020304" pitchFamily="18" charset="0"/>
+                        </a:rPr>
+                        <a:t>, </a:t>
+                      </a:r>
+                      <a:r>
+                        <a:rPr lang="en-IN" sz="1050" b="0" i="0" dirty="0" err="1">
+                          <a:solidFill>
+                            <a:schemeClr val="tx1"/>
+                          </a:solidFill>
+                          <a:effectLst/>
+                          <a:latin typeface="Times New Roman" panose="02020603050405020304" pitchFamily="18" charset="0"/>
+                          <a:cs typeface="Times New Roman" panose="02020603050405020304" pitchFamily="18" charset="0"/>
+                        </a:rPr>
+                        <a:t>schema.sql</a:t>
+                      </a:r>
+                      <a:r>
+                        <a:rPr lang="en-IN" sz="1050" b="0" i="0" dirty="0">
+                          <a:solidFill>
+                            <a:schemeClr val="tx1"/>
+                          </a:solidFill>
+                          <a:effectLst/>
+                          <a:latin typeface="Times New Roman" panose="02020603050405020304" pitchFamily="18" charset="0"/>
+                          <a:cs typeface="Times New Roman" panose="02020603050405020304" pitchFamily="18" charset="0"/>
+                        </a:rPr>
+                        <a:t>, init.js, seed.js</a:t>
                       </a:r>
                     </a:p>
                   </a:txBody>
@@ -5051,21 +5482,32 @@
                   </a:ext>
                 </a:extLst>
               </a:tr>
-              <a:tr h="440029">
-                <a:tc>
-                  <a:txBody>
-                    <a:bodyPr/>
-                    <a:lstStyle/>
-                    <a:p>
-                      <a:pPr>
+              <a:tr h="663203">
+                <a:tc>
+                  <a:txBody>
+                    <a:bodyPr/>
+                    <a:lstStyle/>
+                    <a:p>
+                      <a:pPr indent="0" algn="l">
                         <a:buNone/>
                       </a:pPr>
                       <a:r>
-                        <a:rPr lang="en-IN" sz="1200">
+                        <a:rPr lang="en-IN" sz="1050" b="1" i="0">
+                          <a:solidFill>
+                            <a:schemeClr val="tx1"/>
+                          </a:solidFill>
                           <a:effectLst/>
+                          <a:latin typeface="Segoe WPC"/>
                         </a:rPr>
                         <a:t>5</a:t>
                       </a:r>
+                      <a:endParaRPr lang="en-IN" sz="1050" b="0" i="0">
+                        <a:solidFill>
+                          <a:schemeClr val="tx1"/>
+                        </a:solidFill>
+                        <a:effectLst/>
+                        <a:latin typeface="Segoe WPC"/>
+                      </a:endParaRPr>
                     </a:p>
                   </a:txBody>
                   <a:tcPr anchor="ctr"/>
@@ -5075,18 +5517,28 @@
                     <a:bodyPr/>
                     <a:lstStyle/>
                     <a:p>
-                      <a:pPr>
+                      <a:pPr indent="0" algn="l">
                         <a:buNone/>
                       </a:pPr>
                       <a:r>
-                        <a:rPr lang="en-IN" sz="1200" b="1">
+                        <a:rPr lang="en-IN" sz="1050" b="1" i="0">
+                          <a:solidFill>
+                            <a:schemeClr val="tx1"/>
+                          </a:solidFill>
                           <a:effectLst/>
+                          <a:latin typeface="Times New Roman" panose="02020603050405020304" pitchFamily="18" charset="0"/>
+                          <a:cs typeface="Times New Roman" panose="02020603050405020304" pitchFamily="18" charset="0"/>
                         </a:rPr>
                         <a:t>Real-Time Module</a:t>
                       </a:r>
                       <a:r>
-                        <a:rPr lang="en-IN" sz="1200">
+                        <a:rPr lang="en-IN" sz="1050" b="0" i="0">
+                          <a:solidFill>
+                            <a:schemeClr val="tx1"/>
+                          </a:solidFill>
                           <a:effectLst/>
+                          <a:latin typeface="Times New Roman" panose="02020603050405020304" pitchFamily="18" charset="0"/>
+                          <a:cs typeface="Times New Roman" panose="02020603050405020304" pitchFamily="18" charset="0"/>
                         </a:rPr>
                         <a:t> (WebSocket Layer)</a:t>
                       </a:r>
@@ -5099,12 +5551,17 @@
                     <a:bodyPr/>
                     <a:lstStyle/>
                     <a:p>
-                      <a:pPr>
+                      <a:pPr indent="0" algn="l">
                         <a:buNone/>
                       </a:pPr>
                       <a:r>
-                        <a:rPr lang="en-IN" sz="1200">
+                        <a:rPr lang="en-IN" sz="1050" b="0" i="0">
+                          <a:solidFill>
+                            <a:schemeClr val="tx1"/>
+                          </a:solidFill>
                           <a:effectLst/>
+                          <a:latin typeface="Times New Roman" panose="02020603050405020304" pitchFamily="18" charset="0"/>
+                          <a:cs typeface="Times New Roman" panose="02020603050405020304" pitchFamily="18" charset="0"/>
                         </a:rPr>
                         <a:t>Event-driven pub/sub; room-based sessions; Kahoot-style scoring</a:t>
                       </a:r>
@@ -5117,20 +5574,30 @@
                     <a:bodyPr/>
                     <a:lstStyle/>
                     <a:p>
-                      <a:pPr>
+                      <a:pPr indent="0" algn="l">
                         <a:buNone/>
                       </a:pPr>
                       <a:r>
-                        <a:rPr lang="en-IN" sz="1200" b="1" dirty="0">
+                        <a:rPr lang="en-IN" sz="1050" b="1" i="0">
+                          <a:solidFill>
+                            <a:schemeClr val="tx1"/>
+                          </a:solidFill>
                           <a:effectLst/>
+                          <a:latin typeface="Times New Roman" panose="02020603050405020304" pitchFamily="18" charset="0"/>
+                          <a:cs typeface="Times New Roman" panose="02020603050405020304" pitchFamily="18" charset="0"/>
                         </a:rPr>
                         <a:t>S/W:</a:t>
                       </a:r>
                       <a:r>
-                        <a:rPr lang="en-IN" sz="1200" dirty="0">
+                        <a:rPr lang="en-IN" sz="1050" b="0" i="0">
+                          <a:solidFill>
+                            <a:schemeClr val="tx1"/>
+                          </a:solidFill>
                           <a:effectLst/>
-                        </a:rPr>
-                        <a:t> Socket.IO, Node.js event loop </a:t>
+                          <a:latin typeface="Times New Roman" panose="02020603050405020304" pitchFamily="18" charset="0"/>
+                          <a:cs typeface="Times New Roman" panose="02020603050405020304" pitchFamily="18" charset="0"/>
+                        </a:rPr>
+                        <a:t> Socket.IO, Node.js event loop</a:t>
                       </a:r>
                     </a:p>
                   </a:txBody>
@@ -5141,12 +5608,17 @@
                     <a:bodyPr/>
                     <a:lstStyle/>
                     <a:p>
-                      <a:pPr>
+                      <a:pPr indent="0" algn="l">
                         <a:buNone/>
                       </a:pPr>
                       <a:r>
-                        <a:rPr lang="en-IN" sz="1200" dirty="0">
+                        <a:rPr lang="en-IN" sz="1050" b="0" i="0" dirty="0">
+                          <a:solidFill>
+                            <a:schemeClr val="tx1"/>
+                          </a:solidFill>
                           <a:effectLst/>
+                          <a:latin typeface="Times New Roman" panose="02020603050405020304" pitchFamily="18" charset="0"/>
+                          <a:cs typeface="Times New Roman" panose="02020603050405020304" pitchFamily="18" charset="0"/>
                         </a:rPr>
                         <a:t>Session lifecycle, in-memory store, live scoring &amp; ranking</a:t>
                       </a:r>
@@ -5181,7 +5653,7 @@
           <a:p>
             <a:fld id="{2B573973-4A1E-4C7C-AAB7-BDE9EAC7FD5C}" type="datetime3">
               <a:rPr lang="en-US" smtClean="0"/>
-              <a:t>7 July 2026</a:t>
+              <a:t>10 July 2026</a:t>
             </a:fld>
             <a:endParaRPr lang="en-US" dirty="0"/>
           </a:p>
@@ -5849,8 +6321,8 @@
         </p:blipFill>
         <p:spPr>
           <a:xfrm>
-            <a:off x="4152042" y="359034"/>
-            <a:ext cx="1839421" cy="2021343"/>
+            <a:off x="3838414" y="359034"/>
+            <a:ext cx="2153049" cy="2212716"/>
           </a:xfrm>
           <a:prstGeom prst="rect">
             <a:avLst/>
@@ -5909,7 +6381,7 @@
         </p:blipFill>
         <p:spPr>
           <a:xfrm>
-            <a:off x="3896813" y="2571750"/>
+            <a:off x="4083419" y="2702985"/>
             <a:ext cx="4442251" cy="2165598"/>
           </a:xfrm>
           <a:prstGeom prst="rect">
@@ -5958,7 +6430,7 @@
                   <a:spcPts val="600"/>
                 </a:spcAft>
               </a:pPr>
-              <a:t>7 July 2026</a:t>
+              <a:t>10 July 2026</a:t>
             </a:fld>
             <a:endParaRPr lang="en-US" sz="800">
               <a:solidFill>
@@ -6142,8 +6614,8 @@
         </p:nvSpPr>
         <p:spPr>
           <a:xfrm>
-            <a:off x="191068" y="893929"/>
-            <a:ext cx="8746177" cy="1815882"/>
+            <a:off x="191069" y="893929"/>
+            <a:ext cx="8952932" cy="2308324"/>
           </a:xfrm>
           <a:prstGeom prst="rect">
             <a:avLst/>
@@ -6151,7 +6623,7 @@
           <a:noFill/>
         </p:spPr>
         <p:txBody>
-          <a:bodyPr wrap="none" rtlCol="0">
+          <a:bodyPr wrap="square" rtlCol="0">
             <a:spAutoFit/>
           </a:bodyPr>
           <a:lstStyle/>
@@ -6219,6 +6691,19 @@
                 <a:cs typeface="Times New Roman" pitchFamily="18" charset="0"/>
               </a:rPr>
               <a:t>23 JUNE – 1 JULY : Building a handheld App for Multi Disciplines</a:t>
+            </a:r>
+          </a:p>
+          <a:p>
+            <a:pPr marL="285750" indent="-285750">
+              <a:buFont typeface="Arial" panose="020B0604020202020204" pitchFamily="34" charset="0"/>
+              <a:buChar char="•"/>
+            </a:pPr>
+            <a:r>
+              <a:rPr lang="en-GB" sz="1600" dirty="0">
+                <a:latin typeface="Times New Roman" pitchFamily="18" charset="0"/>
+                <a:cs typeface="Times New Roman" pitchFamily="18" charset="0"/>
+              </a:rPr>
+              <a:t>4 JULY – 9 JULY : Failed to Build a Multi Discipline App. Hosted the current website. Added Admin Role and modified some access roles.</a:t>
             </a:r>
           </a:p>
           <a:p>
@@ -6273,7 +6758,7 @@
           <a:p>
             <a:fld id="{2FFD4BED-E319-4DA0-96BF-17657C6E3A60}" type="datetime3">
               <a:rPr lang="en-US" smtClean="0"/>
-              <a:t>7 July 2026</a:t>
+              <a:t>10 July 2026</a:t>
             </a:fld>
             <a:endParaRPr lang="en-US" dirty="0"/>
           </a:p>
@@ -6832,7 +7317,7 @@
           <a:p>
             <a:fld id="{756D0CD2-9846-482E-BF67-7C2753030DC2}" type="datetime3">
               <a:rPr lang="en-US" smtClean="0"/>
-              <a:t>7 July 2026</a:t>
+              <a:t>10 July 2026</a:t>
             </a:fld>
             <a:endParaRPr lang="en-US" dirty="0"/>
           </a:p>
@@ -7251,7 +7736,7 @@
           <a:p>
             <a:fld id="{24A434A4-5EBF-4C57-A471-F9649EE16CF8}" type="datetime3">
               <a:rPr lang="en-US" smtClean="0"/>
-              <a:t>7 July 2026</a:t>
+              <a:t>10 July 2026</a:t>
             </a:fld>
             <a:endParaRPr lang="en-US" dirty="0"/>
           </a:p>
@@ -7340,7 +7825,7 @@
           <a:p>
             <a:fld id="{2DB9DF8F-09D3-46AE-87C0-0E6AC09D07A6}" type="datetime3">
               <a:rPr lang="en-US" smtClean="0"/>
-              <a:t>7 July 2026</a:t>
+              <a:t>10 July 2026</a:t>
             </a:fld>
             <a:endParaRPr lang="en-US" dirty="0"/>
           </a:p>
@@ -7419,7 +7904,7 @@
         <p:spPr>
           <a:xfrm>
             <a:off x="0" y="102392"/>
-            <a:ext cx="16950922" cy="3693319"/>
+            <a:ext cx="9144000" cy="4247317"/>
           </a:xfrm>
           <a:prstGeom prst="rect">
             <a:avLst/>
@@ -7427,7 +7912,7 @@
           <a:noFill/>
         </p:spPr>
         <p:txBody>
-          <a:bodyPr wrap="none" rtlCol="0">
+          <a:bodyPr wrap="square" rtlCol="0">
             <a:spAutoFit/>
           </a:bodyPr>
           <a:lstStyle/>
@@ -7644,7 +8129,7 @@
           <a:p>
             <a:fld id="{F6B04E1E-CF05-4B41-8802-CD685CA27131}" type="datetime3">
               <a:rPr lang="en-US" smtClean="0"/>
-              <a:t>7 July 2026</a:t>
+              <a:t>10 July 2026</a:t>
             </a:fld>
             <a:endParaRPr lang="en-US" dirty="0"/>
           </a:p>
@@ -7812,147 +8297,8 @@
         </p:nvSpPr>
         <p:spPr>
           <a:xfrm>
-            <a:off x="507820" y="2443171"/>
-            <a:ext cx="4136645" cy="2339102"/>
-          </a:xfrm>
-          <a:prstGeom prst="rect">
-            <a:avLst/>
-          </a:prstGeom>
-          <a:noFill/>
-        </p:spPr>
-        <p:txBody>
-          <a:bodyPr wrap="none" rtlCol="0">
-            <a:spAutoFit/>
-          </a:bodyPr>
-          <a:lstStyle/>
-          <a:p>
-            <a:r>
-              <a:rPr lang="en-GB" b="1" dirty="0">
-                <a:solidFill>
-                  <a:srgbClr val="C00000"/>
-                </a:solidFill>
-                <a:latin typeface="Times New Roman" pitchFamily="18" charset="0"/>
-                <a:cs typeface="Times New Roman" pitchFamily="18" charset="0"/>
-              </a:rPr>
-              <a:t>Applications:</a:t>
-            </a:r>
-          </a:p>
-          <a:p>
-            <a:pPr marL="285750" indent="-285750">
-              <a:buFont typeface="Arial" panose="020B0604020202020204" pitchFamily="34" charset="0"/>
-              <a:buChar char="•"/>
-            </a:pPr>
-            <a:r>
-              <a:rPr lang="en-GB" sz="1600" b="1" dirty="0">
-                <a:latin typeface="Times New Roman" pitchFamily="18" charset="0"/>
-                <a:cs typeface="Times New Roman" pitchFamily="18" charset="0"/>
-              </a:rPr>
-              <a:t>Interactive Learning</a:t>
-            </a:r>
-          </a:p>
-          <a:p>
-            <a:pPr marL="285750" indent="-285750">
-              <a:buFont typeface="Arial" panose="020B0604020202020204" pitchFamily="34" charset="0"/>
-              <a:buChar char="•"/>
-            </a:pPr>
-            <a:r>
-              <a:rPr lang="en-GB" sz="1600" b="1" dirty="0">
-                <a:latin typeface="Times New Roman" pitchFamily="18" charset="0"/>
-                <a:cs typeface="Times New Roman" pitchFamily="18" charset="0"/>
-              </a:rPr>
-              <a:t>Experience points-based level progression</a:t>
-            </a:r>
-          </a:p>
-          <a:p>
-            <a:pPr marL="285750" indent="-285750">
-              <a:buFont typeface="Arial" panose="020B0604020202020204" pitchFamily="34" charset="0"/>
-              <a:buChar char="•"/>
-            </a:pPr>
-            <a:r>
-              <a:rPr lang="en-GB" sz="1600" b="1" dirty="0">
-                <a:latin typeface="Times New Roman" pitchFamily="18" charset="0"/>
-                <a:cs typeface="Times New Roman" pitchFamily="18" charset="0"/>
-              </a:rPr>
-              <a:t>User centric customization</a:t>
-            </a:r>
-          </a:p>
-          <a:p>
-            <a:pPr marL="285750" indent="-285750">
-              <a:buFont typeface="Arial" panose="020B0604020202020204" pitchFamily="34" charset="0"/>
-              <a:buChar char="•"/>
-            </a:pPr>
-            <a:r>
-              <a:rPr lang="en-GB" sz="1600" b="1" dirty="0">
-                <a:latin typeface="Times New Roman" pitchFamily="18" charset="0"/>
-                <a:cs typeface="Times New Roman" pitchFamily="18" charset="0"/>
-              </a:rPr>
-              <a:t>Day to Day Leaderboard Update</a:t>
-            </a:r>
-          </a:p>
-          <a:p>
-            <a:pPr marL="285750" indent="-285750">
-              <a:buFont typeface="Arial" panose="020B0604020202020204" pitchFamily="34" charset="0"/>
-              <a:buChar char="•"/>
-            </a:pPr>
-            <a:r>
-              <a:rPr lang="en-GB" sz="1600" b="1" dirty="0">
-                <a:latin typeface="Times New Roman" pitchFamily="18" charset="0"/>
-                <a:cs typeface="Times New Roman" pitchFamily="18" charset="0"/>
-              </a:rPr>
-              <a:t>Different Question Modes</a:t>
-            </a:r>
-          </a:p>
-          <a:p>
-            <a:pPr marL="285750" indent="-285750">
-              <a:buFont typeface="Arial" panose="020B0604020202020204" pitchFamily="34" charset="0"/>
-              <a:buChar char="•"/>
-            </a:pPr>
-            <a:r>
-              <a:rPr lang="en-GB" sz="1600" b="1" dirty="0">
-                <a:latin typeface="Times New Roman" pitchFamily="18" charset="0"/>
-                <a:cs typeface="Times New Roman" pitchFamily="18" charset="0"/>
-              </a:rPr>
-              <a:t>Domain based Modules</a:t>
-            </a:r>
-          </a:p>
-          <a:p>
-            <a:pPr marL="285750" indent="-285750">
-              <a:buFont typeface="Arial" panose="020B0604020202020204" pitchFamily="34" charset="0"/>
-              <a:buChar char="•"/>
-            </a:pPr>
-            <a:r>
-              <a:rPr lang="en-GB" sz="1600" b="1" dirty="0">
-                <a:latin typeface="Times New Roman" pitchFamily="18" charset="0"/>
-                <a:cs typeface="Times New Roman" pitchFamily="18" charset="0"/>
-              </a:rPr>
-              <a:t>Live Quiz</a:t>
-            </a:r>
-          </a:p>
-          <a:p>
-            <a:pPr marL="285750" indent="-285750">
-              <a:buFont typeface="Arial" panose="020B0604020202020204" pitchFamily="34" charset="0"/>
-              <a:buChar char="•"/>
-            </a:pPr>
-            <a:r>
-              <a:rPr lang="en-GB" sz="1600" b="1" dirty="0">
-                <a:latin typeface="Times New Roman" pitchFamily="18" charset="0"/>
-                <a:cs typeface="Times New Roman" pitchFamily="18" charset="0"/>
-              </a:rPr>
-              <a:t>And more…</a:t>
-            </a:r>
-          </a:p>
-        </p:txBody>
-      </p:sp>
-      <p:sp>
-        <p:nvSpPr>
-          <p:cNvPr id="6" name="TextBox 5"/>
-          <p:cNvSpPr txBox="1"/>
-          <p:nvPr/>
-        </p:nvSpPr>
-        <p:spPr>
-          <a:xfrm>
-            <a:off x="507820" y="655751"/>
-            <a:ext cx="8443767" cy="1600438"/>
+            <a:off x="258305" y="2369823"/>
+            <a:ext cx="6529952" cy="2554545"/>
           </a:xfrm>
           <a:prstGeom prst="rect">
             <a:avLst/>
@@ -7973,18 +8319,161 @@
                 <a:latin typeface="Times New Roman" pitchFamily="18" charset="0"/>
                 <a:cs typeface="Times New Roman" pitchFamily="18" charset="0"/>
               </a:rPr>
-              <a:t>Need for the technology: </a:t>
-            </a:r>
-          </a:p>
-          <a:p>
-            <a:pPr algn="just"/>
-            <a:r>
-              <a:rPr lang="en-GB" sz="1600" b="1" dirty="0">
+              <a:t>Applications:</a:t>
+            </a:r>
+          </a:p>
+          <a:p>
+            <a:pPr marL="285750" indent="-285750">
+              <a:buFont typeface="Arial" panose="020B0604020202020204" pitchFamily="34" charset="0"/>
+              <a:buChar char="•"/>
+            </a:pPr>
+            <a:r>
+              <a:rPr lang="en-IN" dirty="0">
+                <a:latin typeface="Times New Roman" panose="02020603050405020304" pitchFamily="18" charset="0"/>
+                <a:cs typeface="Times New Roman" panose="02020603050405020304" pitchFamily="18" charset="0"/>
+              </a:rPr>
+              <a:t>Interactive &amp; Gamified Learning</a:t>
+            </a:r>
+          </a:p>
+          <a:p>
+            <a:pPr marL="285750" indent="-285750">
+              <a:buFont typeface="Arial" panose="020B0604020202020204" pitchFamily="34" charset="0"/>
+              <a:buChar char="•"/>
+            </a:pPr>
+            <a:r>
+              <a:rPr lang="en-IN" dirty="0">
+                <a:latin typeface="Times New Roman" panose="02020603050405020304" pitchFamily="18" charset="0"/>
+                <a:cs typeface="Times New Roman" panose="02020603050405020304" pitchFamily="18" charset="0"/>
+              </a:rPr>
+              <a:t>Rank &amp; XP-Based Level Progression</a:t>
+            </a:r>
+          </a:p>
+          <a:p>
+            <a:pPr marL="285750" indent="-285750">
+              <a:buFont typeface="Arial" panose="020B0604020202020204" pitchFamily="34" charset="0"/>
+              <a:buChar char="•"/>
+            </a:pPr>
+            <a:r>
+              <a:rPr lang="en-IN" dirty="0">
+                <a:latin typeface="Times New Roman" panose="02020603050405020304" pitchFamily="18" charset="0"/>
+                <a:cs typeface="Times New Roman" panose="02020603050405020304" pitchFamily="18" charset="0"/>
+              </a:rPr>
+              <a:t>User-Centric Customization (Clinical Avatars)</a:t>
+            </a:r>
+          </a:p>
+          <a:p>
+            <a:pPr marL="285750" indent="-285750">
+              <a:buFont typeface="Arial" panose="020B0604020202020204" pitchFamily="34" charset="0"/>
+              <a:buChar char="•"/>
+            </a:pPr>
+            <a:r>
+              <a:rPr lang="en-IN" dirty="0">
+                <a:latin typeface="Times New Roman" panose="02020603050405020304" pitchFamily="18" charset="0"/>
+                <a:cs typeface="Times New Roman" panose="02020603050405020304" pitchFamily="18" charset="0"/>
+              </a:rPr>
+              <a:t>Real-Time &amp; Daily-Resetting Leaderboards</a:t>
+            </a:r>
+          </a:p>
+          <a:p>
+            <a:pPr marL="285750" indent="-285750">
+              <a:buFont typeface="Arial" panose="020B0604020202020204" pitchFamily="34" charset="0"/>
+              <a:buChar char="•"/>
+            </a:pPr>
+            <a:r>
+              <a:rPr lang="en-IN" dirty="0">
+                <a:latin typeface="Times New Roman" panose="02020603050405020304" pitchFamily="18" charset="0"/>
+                <a:cs typeface="Times New Roman" panose="02020603050405020304" pitchFamily="18" charset="0"/>
+              </a:rPr>
+              <a:t>9 Specialized Question Formats (Audio/Video/Clinical scenarios)</a:t>
+            </a:r>
+          </a:p>
+          <a:p>
+            <a:pPr marL="285750" indent="-285750">
+              <a:buFont typeface="Arial" panose="020B0604020202020204" pitchFamily="34" charset="0"/>
+              <a:buChar char="•"/>
+            </a:pPr>
+            <a:r>
+              <a:rPr lang="en-IN" dirty="0">
+                <a:latin typeface="Times New Roman" panose="02020603050405020304" pitchFamily="18" charset="0"/>
+                <a:cs typeface="Times New Roman" panose="02020603050405020304" pitchFamily="18" charset="0"/>
+              </a:rPr>
+              <a:t>Curriculum-Aligned Study Modules</a:t>
+            </a:r>
+          </a:p>
+          <a:p>
+            <a:pPr marL="285750" indent="-285750">
+              <a:buFont typeface="Arial" panose="020B0604020202020204" pitchFamily="34" charset="0"/>
+              <a:buChar char="•"/>
+            </a:pPr>
+            <a:r>
+              <a:rPr lang="en-IN" dirty="0">
+                <a:latin typeface="Times New Roman" panose="02020603050405020304" pitchFamily="18" charset="0"/>
+                <a:cs typeface="Times New Roman" panose="02020603050405020304" pitchFamily="18" charset="0"/>
+              </a:rPr>
+              <a:t>Live Multiplayer Classroom Mode (Socket.IO-powered)</a:t>
+            </a:r>
+          </a:p>
+          <a:p>
+            <a:pPr marL="285750" indent="-285750">
+              <a:buFont typeface="Arial" panose="020B0604020202020204" pitchFamily="34" charset="0"/>
+              <a:buChar char="•"/>
+            </a:pPr>
+            <a:r>
+              <a:rPr lang="en-GB" sz="1600" dirty="0">
+                <a:latin typeface="Times New Roman" panose="02020603050405020304" pitchFamily="18" charset="0"/>
+                <a:cs typeface="Times New Roman" pitchFamily="18" charset="0"/>
+              </a:rPr>
+              <a:t>And more…</a:t>
+            </a:r>
+          </a:p>
+        </p:txBody>
+      </p:sp>
+      <p:sp>
+        <p:nvSpPr>
+          <p:cNvPr id="6" name="TextBox 5"/>
+          <p:cNvSpPr txBox="1"/>
+          <p:nvPr/>
+        </p:nvSpPr>
+        <p:spPr>
+          <a:xfrm>
+            <a:off x="258305" y="433609"/>
+            <a:ext cx="8776513" cy="2031325"/>
+          </a:xfrm>
+          <a:prstGeom prst="rect">
+            <a:avLst/>
+          </a:prstGeom>
+          <a:noFill/>
+        </p:spPr>
+        <p:txBody>
+          <a:bodyPr wrap="square" rtlCol="0">
+            <a:spAutoFit/>
+          </a:bodyPr>
+          <a:lstStyle/>
+          <a:p>
+            <a:r>
+              <a:rPr lang="en-GB" b="1" dirty="0">
+                <a:solidFill>
+                  <a:srgbClr val="C00000"/>
+                </a:solidFill>
                 <a:latin typeface="Times New Roman" pitchFamily="18" charset="0"/>
                 <a:cs typeface="Times New Roman" pitchFamily="18" charset="0"/>
               </a:rPr>
-              <a:t>Domain based platforms are hard to find publicly on the Internet. Usually Interactive Quizzes and Quiz Platforms that are publicly available are general for all and that is user specific. But each domain, each department should have their own basic modules and questions that can be used irrespective of their syllabus. As I am Collaborating with SRIHER’s Nursing Department, this need of technology had fall into my eyes  </a:t>
-            </a:r>
+              <a:t>Need for the technology: </a:t>
+            </a:r>
+          </a:p>
+          <a:p>
+            <a:pPr algn="just"/>
+            <a:r>
+              <a:rPr lang="en-IN" dirty="0">
+                <a:latin typeface="Times New Roman" panose="02020603050405020304" pitchFamily="18" charset="0"/>
+                <a:cs typeface="Times New Roman" panose="02020603050405020304" pitchFamily="18" charset="0"/>
+              </a:rPr>
+              <a:t>Domain-specific interactive learning platforms are scarce in the public domain. While general-purpose quiz systems exist, they lack the specialized modules required for professional academic disciplines. Each clinical domain requires tailored, high-fidelity question types and structured modules that align with their training needs. Through my collaboration with the Nursing Department at SRIHER, this critical gap in medical education technology was identified, prompting the development of a dedicated solution.</a:t>
+            </a:r>
+            <a:endParaRPr lang="en-GB" sz="1600" dirty="0">
+              <a:latin typeface="Times New Roman" panose="02020603050405020304" pitchFamily="18" charset="0"/>
+              <a:cs typeface="Times New Roman" pitchFamily="18" charset="0"/>
+            </a:endParaRPr>
           </a:p>
         </p:txBody>
       </p:sp>
@@ -8005,7 +8494,7 @@
           <a:p>
             <a:fld id="{E019806D-BBF9-4065-82F1-BB4B2025BF7F}" type="datetime3">
               <a:rPr lang="en-US" smtClean="0"/>
-              <a:t>7 July 2026</a:t>
+              <a:t>10 July 2026</a:t>
             </a:fld>
             <a:endParaRPr lang="en-US" dirty="0"/>
           </a:p>
@@ -8094,7 +8583,7 @@
           <a:p>
             <a:fld id="{2DB9DF8F-09D3-46AE-87C0-0E6AC09D07A6}" type="datetime3">
               <a:rPr lang="en-US" smtClean="0"/>
-              <a:t>7 July 2026</a:t>
+              <a:t>10 July 2026</a:t>
             </a:fld>
             <a:endParaRPr lang="en-US" dirty="0"/>
           </a:p>
@@ -8166,7 +8655,7 @@
         <p:spPr>
           <a:xfrm>
             <a:off x="214345" y="216485"/>
-            <a:ext cx="8715309" cy="1846659"/>
+            <a:ext cx="8816001" cy="2092881"/>
           </a:xfrm>
           <a:prstGeom prst="rect">
             <a:avLst/>
@@ -8193,26 +8682,44 @@
           <a:p>
             <a:pPr algn="just"/>
             <a:r>
-              <a:rPr lang="en-GB" sz="1600" b="1" dirty="0">
-                <a:latin typeface="Times New Roman" pitchFamily="18" charset="0"/>
-                <a:cs typeface="Times New Roman" pitchFamily="18" charset="0"/>
+              <a:rPr lang="en-IN" sz="1600" dirty="0">
+                <a:latin typeface="Times New Roman" panose="02020603050405020304" pitchFamily="18" charset="0"/>
+                <a:cs typeface="Times New Roman" panose="02020603050405020304" pitchFamily="18" charset="0"/>
               </a:rPr>
-              <a:t>The Motivation is that a study on how the Gamified or interactive learning implies effective learning among students. As an existing Technology, Kahoot, way ground and </a:t>
-            </a:r>
-            <a:r>
-              <a:rPr lang="en-GB" sz="1600" b="1" dirty="0" err="1">
-                <a:latin typeface="Times New Roman" pitchFamily="18" charset="0"/>
-                <a:cs typeface="Times New Roman" pitchFamily="18" charset="0"/>
+              <a:t>The primary motivation of this study is to investigate how gamified and interactive learning systems can enhance engagement, active recall, and long-term knowledge retention in specialized nursing education. While general-purpose platforms like Kahoot!, </a:t>
+            </a:r>
+            <a:r>
+              <a:rPr lang="en-IN" sz="1600" dirty="0" err="1">
+                <a:latin typeface="Times New Roman" panose="02020603050405020304" pitchFamily="18" charset="0"/>
+                <a:cs typeface="Times New Roman" panose="02020603050405020304" pitchFamily="18" charset="0"/>
+              </a:rPr>
+              <a:t>Wayground</a:t>
+            </a:r>
+            <a:r>
+              <a:rPr lang="en-IN" sz="1600" dirty="0">
+                <a:latin typeface="Times New Roman" panose="02020603050405020304" pitchFamily="18" charset="0"/>
+                <a:cs typeface="Times New Roman" panose="02020603050405020304" pitchFamily="18" charset="0"/>
+              </a:rPr>
+              <a:t>, and </a:t>
+            </a:r>
+            <a:r>
+              <a:rPr lang="en-IN" sz="1600" dirty="0" err="1">
+                <a:latin typeface="Times New Roman" panose="02020603050405020304" pitchFamily="18" charset="0"/>
+                <a:cs typeface="Times New Roman" panose="02020603050405020304" pitchFamily="18" charset="0"/>
               </a:rPr>
               <a:t>Mentimeter</a:t>
             </a:r>
             <a:r>
-              <a:rPr lang="en-GB" sz="1600" b="1" dirty="0">
-                <a:latin typeface="Times New Roman" pitchFamily="18" charset="0"/>
-                <a:cs typeface="Times New Roman" pitchFamily="18" charset="0"/>
+              <a:rPr lang="en-IN" sz="1600" dirty="0">
+                <a:latin typeface="Times New Roman" panose="02020603050405020304" pitchFamily="18" charset="0"/>
+                <a:cs typeface="Times New Roman" panose="02020603050405020304" pitchFamily="18" charset="0"/>
               </a:rPr>
-              <a:t> gives various features and interactivity for students. This makes the learning heartful and easy to remember. So, this motivates to create a Module based quizzes and level-based progression to consistent incoming of specific Department students irrespective of their syllabus. Thus, Motivation is to study the effectiveness   </a:t>
-            </a:r>
+              <a:t> provide high engagement, they are restricted to generic templates and lack domain-specific clinical modules, patient scenario simulations, and long-term student progression systems. By creating a dedicated, syllabus-aligned platform with structured learning modules and clinical-themed progression, this project aims to bridge this gap, driving consistent and motivated student participation within professional healthcare training.</a:t>
+            </a:r>
+            <a:endParaRPr lang="en-GB" sz="1400" dirty="0">
+              <a:latin typeface="Times New Roman" panose="02020603050405020304" pitchFamily="18" charset="0"/>
+              <a:cs typeface="Times New Roman" pitchFamily="18" charset="0"/>
+            </a:endParaRPr>
           </a:p>
         </p:txBody>
       </p:sp>
@@ -8225,7 +8732,7 @@
         <p:spPr>
           <a:xfrm>
             <a:off x="187467" y="2325312"/>
-            <a:ext cx="5686750" cy="2092881"/>
+            <a:ext cx="5402441" cy="2092881"/>
           </a:xfrm>
           <a:prstGeom prst="rect">
             <a:avLst/>
@@ -8255,7 +8762,7 @@
               <a:buChar char="•"/>
             </a:pPr>
             <a:r>
-              <a:rPr lang="en-GB" sz="1600" b="1" dirty="0">
+              <a:rPr lang="en-GB" sz="1600" dirty="0">
                 <a:latin typeface="Times New Roman" pitchFamily="18" charset="0"/>
                 <a:cs typeface="Times New Roman" pitchFamily="18" charset="0"/>
               </a:rPr>
@@ -8268,7 +8775,7 @@
               <a:buChar char="•"/>
             </a:pPr>
             <a:r>
-              <a:rPr lang="en-GB" sz="1600" b="1" dirty="0">
+              <a:rPr lang="en-GB" sz="1600" dirty="0">
                 <a:latin typeface="Times New Roman" pitchFamily="18" charset="0"/>
                 <a:cs typeface="Times New Roman" pitchFamily="18" charset="0"/>
               </a:rPr>
@@ -8281,7 +8788,7 @@
               <a:buChar char="•"/>
             </a:pPr>
             <a:r>
-              <a:rPr lang="en-GB" sz="1600" b="1" dirty="0">
+              <a:rPr lang="en-GB" sz="1600" dirty="0">
                 <a:latin typeface="Times New Roman" pitchFamily="18" charset="0"/>
                 <a:cs typeface="Times New Roman" pitchFamily="18" charset="0"/>
               </a:rPr>
@@ -8294,7 +8801,7 @@
               <a:buChar char="•"/>
             </a:pPr>
             <a:r>
-              <a:rPr lang="en-GB" sz="1600" b="1" dirty="0">
+              <a:rPr lang="en-GB" sz="1600" dirty="0">
                 <a:latin typeface="Times New Roman" pitchFamily="18" charset="0"/>
                 <a:cs typeface="Times New Roman" pitchFamily="18" charset="0"/>
               </a:rPr>
@@ -8307,7 +8814,7 @@
               <a:buChar char="•"/>
             </a:pPr>
             <a:r>
-              <a:rPr lang="en-GB" sz="1600" b="1" dirty="0">
+              <a:rPr lang="en-GB" sz="1600" dirty="0">
                 <a:latin typeface="Times New Roman" pitchFamily="18" charset="0"/>
                 <a:cs typeface="Times New Roman" pitchFamily="18" charset="0"/>
               </a:rPr>
@@ -8320,7 +8827,7 @@
               <a:buChar char="•"/>
             </a:pPr>
             <a:r>
-              <a:rPr lang="en-GB" sz="1600" b="1" dirty="0">
+              <a:rPr lang="en-GB" sz="1600" dirty="0">
                 <a:latin typeface="Times New Roman" pitchFamily="18" charset="0"/>
                 <a:cs typeface="Times New Roman" pitchFamily="18" charset="0"/>
               </a:rPr>
@@ -8333,7 +8840,7 @@
               <a:buChar char="•"/>
             </a:pPr>
             <a:r>
-              <a:rPr lang="en-GB" sz="1600" b="1" dirty="0">
+              <a:rPr lang="en-GB" sz="1600" dirty="0">
                 <a:latin typeface="Times New Roman" pitchFamily="18" charset="0"/>
                 <a:cs typeface="Times New Roman" pitchFamily="18" charset="0"/>
               </a:rPr>
@@ -9651,7 +10158,7 @@
           <a:p>
             <a:fld id="{4E2F8081-A97F-4DB5-8CE1-E687C3C2B1EA}" type="datetime3">
               <a:rPr lang="en-US" smtClean="0"/>
-              <a:t>7 July 2026</a:t>
+              <a:t>10 July 2026</a:t>
             </a:fld>
             <a:endParaRPr lang="en-US" dirty="0"/>
           </a:p>
@@ -10984,7 +11491,7 @@
           <a:p>
             <a:fld id="{79B8DED3-A3EE-40F6-BF5C-4608A21E219C}" type="datetime3">
               <a:rPr lang="en-US" smtClean="0"/>
-              <a:t>7 July 2026</a:t>
+              <a:t>10 July 2026</a:t>
             </a:fld>
             <a:endParaRPr lang="en-US" dirty="0"/>
           </a:p>
@@ -11121,7 +11628,7 @@
           <a:p>
             <a:fld id="{2DB9DF8F-09D3-46AE-87C0-0E6AC09D07A6}" type="datetime3">
               <a:rPr lang="en-US" smtClean="0"/>
-              <a:t>7 July 2026</a:t>
+              <a:t>10 July 2026</a:t>
             </a:fld>
             <a:endParaRPr lang="en-US" dirty="0"/>
           </a:p>
@@ -13046,7 +13553,7 @@
           <a:p>
             <a:fld id="{A677CD66-4046-4467-BD12-ED7F3687165D}" type="datetime3">
               <a:rPr lang="en-US" smtClean="0"/>
-              <a:t>7 July 2026</a:t>
+              <a:t>10 July 2026</a:t>
             </a:fld>
             <a:endParaRPr lang="en-US" dirty="0"/>
           </a:p>
@@ -13140,7 +13647,7 @@
           <a:p>
             <a:fld id="{2DB9DF8F-09D3-46AE-87C0-0E6AC09D07A6}" type="datetime3">
               <a:rPr lang="en-US" smtClean="0"/>
-              <a:t>7 July 2026</a:t>
+              <a:t>10 July 2026</a:t>
             </a:fld>
             <a:endParaRPr lang="en-US" dirty="0"/>
           </a:p>
@@ -14104,8 +14611,8 @@
         </p:nvSpPr>
         <p:spPr>
           <a:xfrm>
-            <a:off x="628651" y="656869"/>
-            <a:ext cx="8337550" cy="4247317"/>
+            <a:off x="495946" y="656869"/>
+            <a:ext cx="8470255" cy="4185761"/>
           </a:xfrm>
           <a:prstGeom prst="rect">
             <a:avLst/>
@@ -14198,10 +14705,10 @@
             <a:pPr algn="just"/>
             <a:r>
               <a:rPr lang="en-IN" sz="1400" dirty="0">
-                <a:latin typeface="Times New Roman" pitchFamily="18" charset="0"/>
-                <a:cs typeface="Times New Roman" pitchFamily="18" charset="0"/>
+                <a:latin typeface="Times New Roman" panose="02020603050405020304" pitchFamily="18" charset="0"/>
+                <a:cs typeface="Times New Roman" panose="02020603050405020304" pitchFamily="18" charset="0"/>
               </a:rPr>
-              <a:t>A full-stack web platform with </a:t>
+              <a:t>A full-stack web platform featuring </a:t>
             </a:r>
             <a:r>
               <a:rPr lang="en-IN" sz="1400" b="1" dirty="0">
@@ -14215,7 +14722,7 @@
                 <a:latin typeface="Times New Roman" panose="02020603050405020304" pitchFamily="18" charset="0"/>
                 <a:cs typeface="Times New Roman" panose="02020603050405020304" pitchFamily="18" charset="0"/>
               </a:rPr>
-              <a:t> (XP, ranks, badges), </a:t>
+              <a:t> (XP, clinical ranks, badges), </a:t>
             </a:r>
             <a:r>
               <a:rPr lang="en-IN" sz="1400" b="1" dirty="0">
@@ -14250,7 +14757,7 @@
                 <a:latin typeface="Times New Roman" panose="02020603050405020304" pitchFamily="18" charset="0"/>
                 <a:cs typeface="Times New Roman" panose="02020603050405020304" pitchFamily="18" charset="0"/>
               </a:rPr>
-              <a:t>6 multimedia question types</a:t>
+              <a:t>9 distinct question types</a:t>
             </a:r>
             <a:r>
               <a:rPr lang="en-IN" sz="1400" dirty="0">
@@ -14264,7 +14771,7 @@
                 <a:latin typeface="Times New Roman" panose="02020603050405020304" pitchFamily="18" charset="0"/>
                 <a:cs typeface="Times New Roman" panose="02020603050405020304" pitchFamily="18" charset="0"/>
               </a:rPr>
-              <a:t>role-based access</a:t>
+              <a:t>role-based access control</a:t>
             </a:r>
             <a:r>
               <a:rPr lang="en-IN" sz="1400" dirty="0">
@@ -14285,7 +14792,28 @@
                 <a:latin typeface="Times New Roman" panose="02020603050405020304" pitchFamily="18" charset="0"/>
                 <a:cs typeface="Times New Roman" panose="02020603050405020304" pitchFamily="18" charset="0"/>
               </a:rPr>
-              <a:t> — built with React 19, Node.js/Express 5, Socket.IO, and SQLite.</a:t>
+              <a:t> — built with React 19, Node.js/Express 5, Socket.IO, and </a:t>
+            </a:r>
+            <a:r>
+              <a:rPr lang="en-IN" sz="1400" b="1" dirty="0" err="1">
+                <a:latin typeface="Times New Roman" panose="02020603050405020304" pitchFamily="18" charset="0"/>
+                <a:cs typeface="Times New Roman" panose="02020603050405020304" pitchFamily="18" charset="0"/>
+              </a:rPr>
+              <a:t>Supabase</a:t>
+            </a:r>
+            <a:r>
+              <a:rPr lang="en-IN" sz="1400" b="1" dirty="0">
+                <a:latin typeface="Times New Roman" panose="02020603050405020304" pitchFamily="18" charset="0"/>
+                <a:cs typeface="Times New Roman" panose="02020603050405020304" pitchFamily="18" charset="0"/>
+              </a:rPr>
+              <a:t> (PostgreSQL)</a:t>
+            </a:r>
+            <a:r>
+              <a:rPr lang="en-IN" sz="1400" dirty="0">
+                <a:latin typeface="Times New Roman" panose="02020603050405020304" pitchFamily="18" charset="0"/>
+                <a:cs typeface="Times New Roman" panose="02020603050405020304" pitchFamily="18" charset="0"/>
+              </a:rPr>
+              <a:t>.</a:t>
             </a:r>
             <a:endParaRPr lang="en-GB" sz="1400" dirty="0">
               <a:latin typeface="Times New Roman" pitchFamily="18" charset="0"/>
@@ -14293,116 +14821,105 @@
             </a:endParaRPr>
           </a:p>
           <a:p>
-            <a:pPr algn="just"/>
-            <a:endParaRPr lang="en-GB" sz="1400" dirty="0">
-              <a:latin typeface="Times New Roman" pitchFamily="18" charset="0"/>
-              <a:cs typeface="Times New Roman" pitchFamily="18" charset="0"/>
-            </a:endParaRPr>
-          </a:p>
-          <a:p>
-            <a:pPr marL="285750" indent="-285750" algn="just">
+            <a:pPr marL="285750" indent="-285750">
               <a:buFont typeface="Arial" panose="020B0604020202020204" pitchFamily="34" charset="0"/>
               <a:buChar char="•"/>
             </a:pPr>
             <a:r>
-              <a:rPr lang="en-GB" sz="1400" dirty="0">
-                <a:latin typeface="Times New Roman" pitchFamily="18" charset="0"/>
-                <a:cs typeface="Times New Roman" pitchFamily="18" charset="0"/>
+              <a:rPr lang="en-IN" sz="1400" b="1" dirty="0">
+                <a:latin typeface="Times New Roman" panose="02020603050405020304" pitchFamily="18" charset="0"/>
+                <a:cs typeface="Times New Roman" panose="02020603050405020304" pitchFamily="18" charset="0"/>
               </a:rPr>
-              <a:t>To create a Web App or an Website for Quiz platform which includes Nursing specific question modules that any Nursing Student can attend irrespective of their Syllabus. </a:t>
-            </a:r>
-          </a:p>
-          <a:p>
-            <a:pPr marL="285750" indent="-285750" algn="just">
+              <a:t>Target Audience &amp; Scope:</a:t>
+            </a:r>
+            <a:r>
+              <a:rPr lang="en-IN" sz="1400" dirty="0">
+                <a:latin typeface="Times New Roman" panose="02020603050405020304" pitchFamily="18" charset="0"/>
+                <a:cs typeface="Times New Roman" panose="02020603050405020304" pitchFamily="18" charset="0"/>
+              </a:rPr>
+              <a:t> Developed a nursing-specific interactive quiz platform accessible to all nursing students for syllabus-independent self-assessment.</a:t>
+            </a:r>
+          </a:p>
+          <a:p>
+            <a:pPr marL="285750" indent="-285750">
               <a:buFont typeface="Arial" panose="020B0604020202020204" pitchFamily="34" charset="0"/>
               <a:buChar char="•"/>
             </a:pPr>
             <a:r>
-              <a:rPr lang="en-GB" sz="1400" dirty="0">
-                <a:latin typeface="Times New Roman" pitchFamily="18" charset="0"/>
-                <a:cs typeface="Times New Roman" pitchFamily="18" charset="0"/>
+              <a:rPr lang="en-IN" sz="1400" b="1" dirty="0">
+                <a:latin typeface="Times New Roman" panose="02020603050405020304" pitchFamily="18" charset="0"/>
+                <a:cs typeface="Times New Roman" panose="02020603050405020304" pitchFamily="18" charset="0"/>
               </a:rPr>
-              <a:t>We’ve used </a:t>
-            </a:r>
-            <a:r>
-              <a:rPr lang="en-GB" sz="1400" dirty="0" err="1">
-                <a:latin typeface="Times New Roman" pitchFamily="18" charset="0"/>
-                <a:cs typeface="Times New Roman" pitchFamily="18" charset="0"/>
+              <a:t>Frontend &amp; Backend Architecture:</a:t>
+            </a:r>
+            <a:r>
+              <a:rPr lang="en-IN" sz="1400" dirty="0">
+                <a:latin typeface="Times New Roman" panose="02020603050405020304" pitchFamily="18" charset="0"/>
+                <a:cs typeface="Times New Roman" panose="02020603050405020304" pitchFamily="18" charset="0"/>
               </a:rPr>
-              <a:t>React+vite</a:t>
-            </a:r>
-            <a:r>
-              <a:rPr lang="en-GB" sz="1400" dirty="0">
-                <a:latin typeface="Times New Roman" pitchFamily="18" charset="0"/>
-                <a:cs typeface="Times New Roman" pitchFamily="18" charset="0"/>
-              </a:rPr>
-              <a:t> and the middleware as Node+Express.js. RESTful API handles the routing, middleware routing, file uploads and DB operations.</a:t>
-            </a:r>
-          </a:p>
-          <a:p>
-            <a:pPr marL="285750" indent="-285750" algn="just">
+              <a:t> Built with React 19 and Vite on the client side, powered by a Node.js and Express 5 backend RESTful API handling routing, file uploads, and controller logic.</a:t>
+            </a:r>
+          </a:p>
+          <a:p>
+            <a:pPr marL="285750" indent="-285750">
               <a:buFont typeface="Arial" panose="020B0604020202020204" pitchFamily="34" charset="0"/>
               <a:buChar char="•"/>
             </a:pPr>
             <a:r>
-              <a:rPr lang="en-GB" sz="1400" dirty="0">
-                <a:latin typeface="Times New Roman" pitchFamily="18" charset="0"/>
-                <a:cs typeface="Times New Roman" pitchFamily="18" charset="0"/>
+              <a:rPr lang="en-IN" sz="1400" b="1" dirty="0">
+                <a:latin typeface="Times New Roman" panose="02020603050405020304" pitchFamily="18" charset="0"/>
+                <a:cs typeface="Times New Roman" panose="02020603050405020304" pitchFamily="18" charset="0"/>
               </a:rPr>
-              <a:t>Using SQLite (better-</a:t>
-            </a:r>
-            <a:r>
-              <a:rPr lang="en-GB" sz="1400" dirty="0" err="1">
-                <a:latin typeface="Times New Roman" pitchFamily="18" charset="0"/>
-                <a:cs typeface="Times New Roman" pitchFamily="18" charset="0"/>
+              <a:t>Cloud Database Integration:</a:t>
+            </a:r>
+            <a:r>
+              <a:rPr lang="en-IN" sz="1400" dirty="0">
+                <a:latin typeface="Times New Roman" panose="02020603050405020304" pitchFamily="18" charset="0"/>
+                <a:cs typeface="Times New Roman" panose="02020603050405020304" pitchFamily="18" charset="0"/>
               </a:rPr>
-              <a:t>sqlite</a:t>
-            </a:r>
-            <a:r>
-              <a:rPr lang="en-GB" sz="1400" dirty="0">
-                <a:latin typeface="Times New Roman" pitchFamily="18" charset="0"/>
-                <a:cs typeface="Times New Roman" pitchFamily="18" charset="0"/>
+              <a:t> Utilizes </a:t>
+            </a:r>
+            <a:r>
+              <a:rPr lang="en-IN" sz="1400" b="1" dirty="0" err="1">
+                <a:latin typeface="Times New Roman" panose="02020603050405020304" pitchFamily="18" charset="0"/>
+                <a:cs typeface="Times New Roman" panose="02020603050405020304" pitchFamily="18" charset="0"/>
               </a:rPr>
-              <a:t>) for serverless, lightweight use for Database.  </a:t>
-            </a:r>
-          </a:p>
-          <a:p>
-            <a:pPr marL="285750" indent="-285750" algn="just">
+              <a:t>Supabase</a:t>
+            </a:r>
+            <a:r>
+              <a:rPr lang="en-IN" sz="1400" b="1" dirty="0">
+                <a:latin typeface="Times New Roman" panose="02020603050405020304" pitchFamily="18" charset="0"/>
+                <a:cs typeface="Times New Roman" panose="02020603050405020304" pitchFamily="18" charset="0"/>
+              </a:rPr>
+              <a:t> (PostgreSQL)</a:t>
+            </a:r>
+            <a:r>
+              <a:rPr lang="en-IN" sz="1400" dirty="0">
+                <a:latin typeface="Times New Roman" panose="02020603050405020304" pitchFamily="18" charset="0"/>
+                <a:cs typeface="Times New Roman" panose="02020603050405020304" pitchFamily="18" charset="0"/>
+              </a:rPr>
+              <a:t> with connection pooling to ensure secure, persistent, and scalable relational data storage.</a:t>
+            </a:r>
+          </a:p>
+          <a:p>
+            <a:pPr marL="285750" indent="-285750">
               <a:buFont typeface="Arial" panose="020B0604020202020204" pitchFamily="34" charset="0"/>
               <a:buChar char="•"/>
             </a:pPr>
             <a:r>
-              <a:rPr lang="en-GB" sz="1400" dirty="0">
-                <a:latin typeface="Times New Roman" pitchFamily="18" charset="0"/>
-                <a:cs typeface="Times New Roman" pitchFamily="18" charset="0"/>
+              <a:rPr lang="en-IN" sz="1400" b="1" dirty="0">
+                <a:latin typeface="Times New Roman" panose="02020603050405020304" pitchFamily="18" charset="0"/>
+                <a:cs typeface="Times New Roman" panose="02020603050405020304" pitchFamily="18" charset="0"/>
               </a:rPr>
-              <a:t>Web Sockets </a:t>
-            </a:r>
-            <a:r>
-              <a:rPr lang="en-US" sz="1400" dirty="0">
-                <a:latin typeface="Times New Roman" pitchFamily="18" charset="0"/>
-                <a:cs typeface="Times New Roman" pitchFamily="18" charset="0"/>
+              <a:t>WebSocket Integration:</a:t>
+            </a:r>
+            <a:r>
+              <a:rPr lang="en-IN" sz="1400" dirty="0">
+                <a:latin typeface="Times New Roman" panose="02020603050405020304" pitchFamily="18" charset="0"/>
+                <a:cs typeface="Times New Roman" panose="02020603050405020304" pitchFamily="18" charset="0"/>
               </a:rPr>
-              <a:t>to enable live, real-time </a:t>
-            </a:r>
-            <a:r>
-              <a:rPr lang="en-US" sz="1400" dirty="0" err="1">
-                <a:latin typeface="Times New Roman" pitchFamily="18" charset="0"/>
-                <a:cs typeface="Times New Roman" pitchFamily="18" charset="0"/>
-              </a:rPr>
-              <a:t>multiplayerquiz</a:t>
-            </a:r>
-            <a:r>
-              <a:rPr lang="en-US" sz="1400" dirty="0">
-                <a:latin typeface="Times New Roman" pitchFamily="18" charset="0"/>
-                <a:cs typeface="Times New Roman" pitchFamily="18" charset="0"/>
-              </a:rPr>
-              <a:t> sessions where a teacher hosts and students join via a game code.</a:t>
-            </a:r>
-            <a:endParaRPr lang="en-GB" sz="1400" dirty="0">
-              <a:latin typeface="Times New Roman" pitchFamily="18" charset="0"/>
-              <a:cs typeface="Times New Roman" pitchFamily="18" charset="0"/>
-            </a:endParaRPr>
+              <a:t> Integrated Socket.IO to enable live, real-time multiplayer quiz sessions where a teacher hosts and students join via a 6-digit game code.</a:t>
+            </a:r>
           </a:p>
         </p:txBody>
       </p:sp>
@@ -14423,7 +14940,7 @@
           <a:p>
             <a:fld id="{5A880E69-CE3A-4D4E-8C11-95F4E85341CB}" type="datetime3">
               <a:rPr lang="en-US" smtClean="0"/>
-              <a:t>7 July 2026</a:t>
+              <a:t>10 July 2026</a:t>
             </a:fld>
             <a:endParaRPr lang="en-US" dirty="0"/>
           </a:p>

</xml_diff>